<commit_message>
draft: connect presentation process arrows
</commit_message>
<xml_diff>
--- a/output/presentations/AI-analytics-review-platform-MTS-DRAFT.pptx
+++ b/output/presentations/AI-analytics-review-platform-MTS-DRAFT.pptx
@@ -2,18 +2,18 @@
 <file path=ppt/presentation.xml><?xml version="1.0" encoding="utf-8"?>
 <p:presentation xmlns:p="http://schemas.openxmlformats.org/presentationml/2006/main">
   <p:sldMasterIdLst>
-    <p:sldMasterId xmlns:r="http://schemas.openxmlformats.org/officeDocument/2006/relationships" id="2147483648" r:id="R1b63cd91cf0f4ea1"/>
+    <p:sldMasterId xmlns:r="http://schemas.openxmlformats.org/officeDocument/2006/relationships" id="2147483648" r:id="Rcb0d0076608e4ff0"/>
   </p:sldMasterIdLst>
   <p:notesMasterIdLst>
-    <p:notesMasterId xmlns:r="http://schemas.openxmlformats.org/officeDocument/2006/relationships" r:id="R24c51b8c5f294dca"/>
+    <p:notesMasterId xmlns:r="http://schemas.openxmlformats.org/officeDocument/2006/relationships" r:id="Rd0be81fe0564457b"/>
   </p:notesMasterIdLst>
   <p:sldIdLst>
-    <p:sldId xmlns:r="http://schemas.openxmlformats.org/officeDocument/2006/relationships" id="256" r:id="Ra6cc553922bd4fe6"/>
-    <p:sldId xmlns:r="http://schemas.openxmlformats.org/officeDocument/2006/relationships" id="257" r:id="R445a851148074e4a"/>
-    <p:sldId xmlns:r="http://schemas.openxmlformats.org/officeDocument/2006/relationships" id="258" r:id="R035296ca511e40cd"/>
-    <p:sldId xmlns:r="http://schemas.openxmlformats.org/officeDocument/2006/relationships" id="259" r:id="Rc14c4d59c54d4ce7"/>
-    <p:sldId xmlns:r="http://schemas.openxmlformats.org/officeDocument/2006/relationships" id="260" r:id="Rb3149ba09a7c4f59"/>
-    <p:sldId xmlns:r="http://schemas.openxmlformats.org/officeDocument/2006/relationships" id="261" r:id="R95acec03ab1c4b1a"/>
+    <p:sldId xmlns:r="http://schemas.openxmlformats.org/officeDocument/2006/relationships" id="256" r:id="R313f53c951b24ae8"/>
+    <p:sldId xmlns:r="http://schemas.openxmlformats.org/officeDocument/2006/relationships" id="257" r:id="R3e0c7a1cc7434bee"/>
+    <p:sldId xmlns:r="http://schemas.openxmlformats.org/officeDocument/2006/relationships" id="258" r:id="R942001dc98e04b7e"/>
+    <p:sldId xmlns:r="http://schemas.openxmlformats.org/officeDocument/2006/relationships" id="259" r:id="R01f30281623a4d06"/>
+    <p:sldId xmlns:r="http://schemas.openxmlformats.org/officeDocument/2006/relationships" id="260" r:id="R0894c0d20e6a4755"/>
+    <p:sldId xmlns:r="http://schemas.openxmlformats.org/officeDocument/2006/relationships" id="261" r:id="Ra7a9d80ca0c444cf"/>
   </p:sldIdLst>
   <p:sldSz cx="12192000" cy="6858000"/>
   <p:notesSz cx="6858000" cy="9144000"/>
@@ -363,15 +363,6 @@
             </a:outerShdw>
           </a:effectLst>
         </a:effectStyle>
-        <a:effectStyle>
-          <a:effectLst>
-            <a:outerShdw blurRad="142875" dist="69343" dir="4443276">
-              <a:srgbClr val="000000">
-                <a:alpha val="18000"/>
-              </a:srgbClr>
-            </a:outerShdw>
-          </a:effectLst>
-        </a:effectStyle>
       </a:effectStyleLst>
       <a:bgFillStyleLst>
         <a:solidFill>
@@ -1044,7 +1035,7 @@
   </p:cSld>
   <p:clrMap bg1="lt1" tx1="dk1" bg2="lt2" tx2="dk2" accent1="accent1" accent2="accent2" accent3="accent3" accent4="accent4" accent5="accent5" accent6="accent6" hlink="hlink" folHlink="folHlink"/>
   <p:sldLayoutIdLst>
-    <p:sldLayoutId xmlns:r="http://schemas.openxmlformats.org/officeDocument/2006/relationships" id="2147483649" r:id="R2092da32d6e24555"/>
+    <p:sldLayoutId xmlns:r="http://schemas.openxmlformats.org/officeDocument/2006/relationships" id="2147483649" r:id="R18c4a33786ae437a"/>
   </p:sldLayoutIdLst>
   <p:txStyles>
     <p:titleStyle>
@@ -1922,13 +1913,9 @@
           <a:prstGeom xmlns:a="http://schemas.openxmlformats.org/drawingml/2006/main" prst="rightArrow">
             <a:avLst/>
           </a:prstGeom>
-          <a:solidFill xmlns:a="http://schemas.openxmlformats.org/drawingml/2006/main">
-            <a:srgbClr val="202124"/>
-          </a:solidFill>
-          <a:ln xmlns:a="http://schemas.openxmlformats.org/drawingml/2006/main" w="9525">
-            <a:solidFill>
-              <a:srgbClr val="202124"/>
-            </a:solidFill>
+          <a:noFill xmlns:a="http://schemas.openxmlformats.org/drawingml/2006/main"/>
+          <a:ln xmlns:a="http://schemas.openxmlformats.org/drawingml/2006/main" w="0">
+            <a:noFill/>
             <a:prstDash val="solid"/>
           </a:ln>
         </p:spPr>
@@ -1955,13 +1942,9 @@
           <a:prstGeom xmlns:a="http://schemas.openxmlformats.org/drawingml/2006/main" prst="rightArrow">
             <a:avLst/>
           </a:prstGeom>
-          <a:solidFill xmlns:a="http://schemas.openxmlformats.org/drawingml/2006/main">
-            <a:srgbClr val="202124"/>
-          </a:solidFill>
-          <a:ln xmlns:a="http://schemas.openxmlformats.org/drawingml/2006/main" w="9525">
-            <a:solidFill>
-              <a:srgbClr val="202124"/>
-            </a:solidFill>
+          <a:noFill xmlns:a="http://schemas.openxmlformats.org/drawingml/2006/main"/>
+          <a:ln xmlns:a="http://schemas.openxmlformats.org/drawingml/2006/main" w="0">
+            <a:noFill/>
             <a:prstDash val="solid"/>
           </a:ln>
         </p:spPr>
@@ -2557,13 +2540,9 @@
           <a:prstGeom xmlns:a="http://schemas.openxmlformats.org/drawingml/2006/main" prst="rightArrow">
             <a:avLst/>
           </a:prstGeom>
-          <a:solidFill xmlns:a="http://schemas.openxmlformats.org/drawingml/2006/main">
-            <a:srgbClr val="202124"/>
-          </a:solidFill>
-          <a:ln xmlns:a="http://schemas.openxmlformats.org/drawingml/2006/main" w="9525">
-            <a:solidFill>
-              <a:srgbClr val="202124"/>
-            </a:solidFill>
+          <a:noFill xmlns:a="http://schemas.openxmlformats.org/drawingml/2006/main"/>
+          <a:ln xmlns:a="http://schemas.openxmlformats.org/drawingml/2006/main" w="0">
+            <a:noFill/>
             <a:prstDash val="solid"/>
           </a:ln>
         </p:spPr>
@@ -2590,13 +2569,9 @@
           <a:prstGeom xmlns:a="http://schemas.openxmlformats.org/drawingml/2006/main" prst="rightArrow">
             <a:avLst/>
           </a:prstGeom>
-          <a:solidFill xmlns:a="http://schemas.openxmlformats.org/drawingml/2006/main">
-            <a:srgbClr val="202124"/>
-          </a:solidFill>
-          <a:ln xmlns:a="http://schemas.openxmlformats.org/drawingml/2006/main" w="9525">
-            <a:solidFill>
-              <a:srgbClr val="202124"/>
-            </a:solidFill>
+          <a:noFill xmlns:a="http://schemas.openxmlformats.org/drawingml/2006/main"/>
+          <a:ln xmlns:a="http://schemas.openxmlformats.org/drawingml/2006/main" w="0">
+            <a:noFill/>
             <a:prstDash val="solid"/>
           </a:ln>
         </p:spPr>
@@ -3048,141 +3023,277 @@
           <a:prstGeom xmlns:a="http://schemas.openxmlformats.org/drawingml/2006/main" prst="leftArrow">
             <a:avLst/>
           </a:prstGeom>
-          <a:solidFill xmlns:a="http://schemas.openxmlformats.org/drawingml/2006/main">
-            <a:srgbClr val="202124"/>
-          </a:solidFill>
-          <a:ln xmlns:a="http://schemas.openxmlformats.org/drawingml/2006/main" w="9525">
+          <a:noFill xmlns:a="http://schemas.openxmlformats.org/drawingml/2006/main"/>
+          <a:ln xmlns:a="http://schemas.openxmlformats.org/drawingml/2006/main" w="0">
+            <a:noFill/>
+            <a:prstDash val="solid"/>
+          </a:ln>
+        </p:spPr>
+      </p:sp>
+      <p:sp>
+        <p:nvSpPr>
+          <p:cNvPr id="30" name="return-caption">
+            <a:extLst xmlns:a="http://schemas.openxmlformats.org/drawingml/2006/main">
+              <a:ext uri="{FF2B5EF4-FFF2-40B4-BE49-F238E27FC236}">
+                <a16:creationId xmlns:a16="http://schemas.microsoft.com/office/drawing/2014/main" id="{B0F8A3AC-0E32-442D-819F-6D6E5DFAF304}"/>
+              </a:ext>
+            </a:extLst>
+          </p:cNvPr>
+          <p:cNvSpPr>
+            <a:spLocks xmlns:a="http://schemas.openxmlformats.org/drawingml/2006/main" noGrp="1"/>
+          </p:cNvSpPr>
+          <p:nvPr/>
+        </p:nvSpPr>
+        <p:spPr>
+          <a:xfrm xmlns:a="http://schemas.openxmlformats.org/drawingml/2006/main">
+            <a:off x="3619500" y="5486400"/>
+            <a:ext cx="4476750" cy="247650"/>
+          </a:xfrm>
+          <a:prstGeom xmlns:a="http://schemas.openxmlformats.org/drawingml/2006/main" prst="rect">
+            <a:avLst/>
+          </a:prstGeom>
+          <a:noFill xmlns:a="http://schemas.openxmlformats.org/drawingml/2006/main"/>
+          <a:ln xmlns:a="http://schemas.openxmlformats.org/drawingml/2006/main" w="0">
+            <a:noFill/>
+            <a:prstDash val="solid"/>
+          </a:ln>
+        </p:spPr>
+        <p:txBody>
+          <a:bodyPr xmlns:a="http://schemas.openxmlformats.org/drawingml/2006/main" wrap="square" lIns="57150" tIns="38100" rIns="57150" bIns="38100" anchor="ctr">
+            <a:normAutofit fontScale="100000"/>
+          </a:bodyPr>
+          <a:lstStyle xmlns:a="http://schemas.openxmlformats.org/drawingml/2006/main"/>
+          <a:p xmlns:a="http://schemas.openxmlformats.org/drawingml/2006/main">
+            <a:pPr algn="ctr">
+              <a:lnSpc>
+                <a:spcPct val="100000"/>
+              </a:lnSpc>
+              <a:buNone/>
+              <a:defRPr sz="1125" b="0">
+                <a:solidFill>
+                  <a:srgbClr val="202124"/>
+                </a:solidFill>
+                <a:latin typeface="Arial"/>
+                <a:ea typeface="Arial"/>
+                <a:cs typeface="Arial"/>
+              </a:defRPr>
+            </a:pPr>
+            <a:r>
+              <a:rPr sz="1125" b="0">
+                <a:solidFill>
+                  <a:srgbClr val="202124"/>
+                </a:solidFill>
+                <a:latin typeface="Arial"/>
+                <a:ea typeface="Arial"/>
+                <a:cs typeface="Arial"/>
+              </a:rPr>
+              <a:t>короткая петля: уточнение возвращается аналитику</a:t>
+            </a:r>
+          </a:p>
+        </p:txBody>
+      </p:sp>
+      <p:sp>
+        <p:nvSpPr>
+          <p:cNvPr id="31" name="discipline-1">
+            <a:extLst xmlns:a="http://schemas.openxmlformats.org/drawingml/2006/main">
+              <a:ext uri="{FF2B5EF4-FFF2-40B4-BE49-F238E27FC236}">
+                <a16:creationId xmlns:a16="http://schemas.microsoft.com/office/drawing/2014/main" id="{56261578-717D-4F6C-8511-AB4DAB2917E8}"/>
+              </a:ext>
+            </a:extLst>
+          </p:cNvPr>
+          <p:cNvSpPr>
+            <a:spLocks xmlns:a="http://schemas.openxmlformats.org/drawingml/2006/main" noGrp="1"/>
+          </p:cNvSpPr>
+          <p:nvPr/>
+        </p:nvSpPr>
+        <p:spPr>
+          <a:xfrm xmlns:a="http://schemas.openxmlformats.org/drawingml/2006/main">
+            <a:off x="609600" y="6096000"/>
+            <a:ext cx="10972800" cy="323850"/>
+          </a:xfrm>
+          <a:prstGeom xmlns:a="http://schemas.openxmlformats.org/drawingml/2006/main" prst="rect">
+            <a:avLst/>
+          </a:prstGeom>
+          <a:noFill xmlns:a="http://schemas.openxmlformats.org/drawingml/2006/main"/>
+          <a:ln xmlns:a="http://schemas.openxmlformats.org/drawingml/2006/main" w="0">
+            <a:noFill/>
+            <a:prstDash val="solid"/>
+          </a:ln>
+        </p:spPr>
+        <p:txBody>
+          <a:bodyPr xmlns:a="http://schemas.openxmlformats.org/drawingml/2006/main" wrap="square" lIns="57150" tIns="38100" rIns="57150" bIns="38100" anchor="ctr">
+            <a:normAutofit fontScale="100000"/>
+          </a:bodyPr>
+          <a:lstStyle xmlns:a="http://schemas.openxmlformats.org/drawingml/2006/main"/>
+          <a:p xmlns:a="http://schemas.openxmlformats.org/drawingml/2006/main">
+            <a:pPr algn="ctr">
+              <a:lnSpc>
+                <a:spcPct val="100000"/>
+              </a:lnSpc>
+              <a:buNone/>
+              <a:defRPr sz="1425" b="1">
+                <a:solidFill>
+                  <a:srgbClr val="B80D18"/>
+                </a:solidFill>
+                <a:latin typeface="Arial"/>
+                <a:ea typeface="Arial"/>
+                <a:cs typeface="Arial"/>
+              </a:defRPr>
+            </a:pPr>
+            <a:r>
+              <a:rPr sz="1425" b="1">
+                <a:solidFill>
+                  <a:srgbClr val="B80D18"/>
+                </a:solidFill>
+                <a:latin typeface="Arial"/>
+                <a:ea typeface="Arial"/>
+                <a:cs typeface="Arial"/>
+              </a:rPr>
+              <a:t>Тот же принцип качества — но на шаг раньше.</a:t>
+            </a:r>
+          </a:p>
+        </p:txBody>
+      </p:sp>
+      <p:cxnSp>
+        <p:nvCxnSpPr>
+          <p:cNvPr id="69" name=""/>
+          <p:cNvCxnSpPr>
+            <a:stCxn xmlns:a="http://schemas.openxmlformats.org/drawingml/2006/main" id="10" idx="3"/>
+            <a:endCxn xmlns:a="http://schemas.openxmlformats.org/drawingml/2006/main" id="11" idx="1"/>
+          </p:cNvCxnSpPr>
+          <p:nvPr/>
+        </p:nvCxnSpPr>
+        <p:spPr>
+          <a:xfrm xmlns:a="http://schemas.openxmlformats.org/drawingml/2006/main" flipV="1">
+            <a:off x="3009722" y="2902016"/>
+            <a:ext cx="1990991" cy="33779"/>
+          </a:xfrm>
+          <a:prstGeom xmlns:a="http://schemas.openxmlformats.org/drawingml/2006/main" prst="straightConnector1">
+            <a:avLst/>
+          </a:prstGeom>
+          <a:ln xmlns:a="http://schemas.openxmlformats.org/drawingml/2006/main" w="26670" cap="rnd">
             <a:solidFill>
               <a:srgbClr val="202124"/>
             </a:solidFill>
             <a:prstDash val="solid"/>
-          </a:ln>
-        </p:spPr>
-      </p:sp>
-      <p:sp>
-        <p:nvSpPr>
-          <p:cNvPr id="30" name="return-caption">
-            <a:extLst xmlns:a="http://schemas.openxmlformats.org/drawingml/2006/main">
-              <a:ext uri="{FF2B5EF4-FFF2-40B4-BE49-F238E27FC236}">
-                <a16:creationId xmlns:a16="http://schemas.microsoft.com/office/drawing/2014/main" id="{B0F8A3AC-0E32-442D-819F-6D6E5DFAF304}"/>
-              </a:ext>
-            </a:extLst>
-          </p:cNvPr>
-          <p:cNvSpPr>
-            <a:spLocks xmlns:a="http://schemas.openxmlformats.org/drawingml/2006/main" noGrp="1"/>
-          </p:cNvSpPr>
-          <p:nvPr/>
-        </p:nvSpPr>
-        <p:spPr>
-          <a:xfrm xmlns:a="http://schemas.openxmlformats.org/drawingml/2006/main">
-            <a:off x="3619500" y="5486400"/>
-            <a:ext cx="4476750" cy="247650"/>
-          </a:xfrm>
-          <a:prstGeom xmlns:a="http://schemas.openxmlformats.org/drawingml/2006/main" prst="rect">
-            <a:avLst/>
-          </a:prstGeom>
-          <a:noFill xmlns:a="http://schemas.openxmlformats.org/drawingml/2006/main"/>
-          <a:ln xmlns:a="http://schemas.openxmlformats.org/drawingml/2006/main" w="0">
-            <a:noFill/>
-            <a:prstDash val="solid"/>
-          </a:ln>
-        </p:spPr>
-        <p:txBody>
-          <a:bodyPr xmlns:a="http://schemas.openxmlformats.org/drawingml/2006/main" wrap="square" lIns="57150" tIns="38100" rIns="57150" bIns="38100" anchor="ctr">
-            <a:normAutofit fontScale="100000"/>
-          </a:bodyPr>
-          <a:lstStyle xmlns:a="http://schemas.openxmlformats.org/drawingml/2006/main"/>
-          <a:p xmlns:a="http://schemas.openxmlformats.org/drawingml/2006/main">
-            <a:pPr algn="ctr">
-              <a:lnSpc>
-                <a:spcPct val="100000"/>
-              </a:lnSpc>
-              <a:buNone/>
-              <a:defRPr sz="1125" b="0">
-                <a:solidFill>
-                  <a:srgbClr val="202124"/>
-                </a:solidFill>
-                <a:latin typeface="Arial"/>
-                <a:ea typeface="Arial"/>
-                <a:cs typeface="Arial"/>
-              </a:defRPr>
-            </a:pPr>
-            <a:r>
-              <a:rPr sz="1125" b="0">
-                <a:solidFill>
-                  <a:srgbClr val="202124"/>
-                </a:solidFill>
-                <a:latin typeface="Arial"/>
-                <a:ea typeface="Arial"/>
-                <a:cs typeface="Arial"/>
-              </a:rPr>
-              <a:t>короткая петля: уточнение возвращается аналитику</a:t>
-            </a:r>
-          </a:p>
-        </p:txBody>
-      </p:sp>
-      <p:sp>
-        <p:nvSpPr>
-          <p:cNvPr id="31" name="discipline-1">
-            <a:extLst xmlns:a="http://schemas.openxmlformats.org/drawingml/2006/main">
-              <a:ext uri="{FF2B5EF4-FFF2-40B4-BE49-F238E27FC236}">
-                <a16:creationId xmlns:a16="http://schemas.microsoft.com/office/drawing/2014/main" id="{56261578-717D-4F6C-8511-AB4DAB2917E8}"/>
-              </a:ext>
-            </a:extLst>
-          </p:cNvPr>
-          <p:cNvSpPr>
-            <a:spLocks xmlns:a="http://schemas.openxmlformats.org/drawingml/2006/main" noGrp="1"/>
-          </p:cNvSpPr>
-          <p:nvPr/>
-        </p:nvSpPr>
-        <p:spPr>
-          <a:xfrm xmlns:a="http://schemas.openxmlformats.org/drawingml/2006/main">
-            <a:off x="609600" y="6096000"/>
-            <a:ext cx="10972800" cy="323850"/>
-          </a:xfrm>
-          <a:prstGeom xmlns:a="http://schemas.openxmlformats.org/drawingml/2006/main" prst="rect">
-            <a:avLst/>
-          </a:prstGeom>
-          <a:noFill xmlns:a="http://schemas.openxmlformats.org/drawingml/2006/main"/>
-          <a:ln xmlns:a="http://schemas.openxmlformats.org/drawingml/2006/main" w="0">
-            <a:noFill/>
-            <a:prstDash val="solid"/>
-          </a:ln>
-        </p:spPr>
-        <p:txBody>
-          <a:bodyPr xmlns:a="http://schemas.openxmlformats.org/drawingml/2006/main" wrap="square" lIns="57150" tIns="38100" rIns="57150" bIns="38100" anchor="ctr">
-            <a:normAutofit fontScale="100000"/>
-          </a:bodyPr>
-          <a:lstStyle xmlns:a="http://schemas.openxmlformats.org/drawingml/2006/main"/>
-          <a:p xmlns:a="http://schemas.openxmlformats.org/drawingml/2006/main">
-            <a:pPr algn="ctr">
-              <a:lnSpc>
-                <a:spcPct val="100000"/>
-              </a:lnSpc>
-              <a:buNone/>
-              <a:defRPr sz="1425" b="1">
-                <a:solidFill>
-                  <a:srgbClr val="B80D18"/>
-                </a:solidFill>
-                <a:latin typeface="Arial"/>
-                <a:ea typeface="Arial"/>
-                <a:cs typeface="Arial"/>
-              </a:defRPr>
-            </a:pPr>
-            <a:r>
-              <a:rPr sz="1425" b="1">
-                <a:solidFill>
-                  <a:srgbClr val="B80D18"/>
-                </a:solidFill>
-                <a:latin typeface="Arial"/>
-                <a:ea typeface="Arial"/>
-                <a:cs typeface="Arial"/>
-              </a:rPr>
-              <a:t>Тот же принцип качества — но на шаг раньше.</a:t>
-            </a:r>
-          </a:p>
-        </p:txBody>
-      </p:sp>
+            <a:round/>
+            <a:headEnd type="none" w="med" len="med"/>
+            <a:tailEnd type="triangle" w="med" len="med"/>
+          </a:ln>
+        </p:spPr>
+      </p:cxnSp>
+      <p:cxnSp>
+        <p:nvCxnSpPr>
+          <p:cNvPr id="70" name=""/>
+          <p:cNvCxnSpPr>
+            <a:stCxn xmlns:a="http://schemas.openxmlformats.org/drawingml/2006/main" id="11" idx="3"/>
+            <a:endCxn xmlns:a="http://schemas.openxmlformats.org/drawingml/2006/main" id="12" idx="1"/>
+          </p:cNvCxnSpPr>
+          <p:nvPr/>
+        </p:nvCxnSpPr>
+        <p:spPr>
+          <a:xfrm xmlns:a="http://schemas.openxmlformats.org/drawingml/2006/main">
+            <a:off x="6810287" y="2927284"/>
+            <a:ext cx="1886187" cy="9923"/>
+          </a:xfrm>
+          <a:prstGeom xmlns:a="http://schemas.openxmlformats.org/drawingml/2006/main" prst="straightConnector1">
+            <a:avLst/>
+          </a:prstGeom>
+          <a:ln xmlns:a="http://schemas.openxmlformats.org/drawingml/2006/main" w="26670" cap="rnd">
+            <a:solidFill>
+              <a:srgbClr val="202124"/>
+            </a:solidFill>
+            <a:prstDash val="solid"/>
+            <a:round/>
+            <a:headEnd type="none" w="med" len="med"/>
+            <a:tailEnd type="triangle" w="med" len="med"/>
+          </a:ln>
+        </p:spPr>
+      </p:cxnSp>
+      <p:cxnSp>
+        <p:nvCxnSpPr>
+          <p:cNvPr id="71" name=""/>
+          <p:cNvCxnSpPr>
+            <a:stCxn xmlns:a="http://schemas.openxmlformats.org/drawingml/2006/main" id="22" idx="3"/>
+            <a:endCxn xmlns:a="http://schemas.openxmlformats.org/drawingml/2006/main" id="23" idx="1"/>
+          </p:cNvCxnSpPr>
+          <p:nvPr/>
+        </p:nvCxnSpPr>
+        <p:spPr>
+          <a:xfrm xmlns:a="http://schemas.openxmlformats.org/drawingml/2006/main" flipV="1">
+            <a:off x="3105019" y="4897962"/>
+            <a:ext cx="1848052" cy="50949"/>
+          </a:xfrm>
+          <a:prstGeom xmlns:a="http://schemas.openxmlformats.org/drawingml/2006/main" prst="straightConnector1">
+            <a:avLst/>
+          </a:prstGeom>
+          <a:ln xmlns:a="http://schemas.openxmlformats.org/drawingml/2006/main" w="26670" cap="rnd">
+            <a:solidFill>
+              <a:srgbClr val="202124"/>
+            </a:solidFill>
+            <a:prstDash val="solid"/>
+            <a:round/>
+            <a:headEnd type="none" w="med" len="med"/>
+            <a:tailEnd type="triangle" w="med" len="med"/>
+          </a:ln>
+        </p:spPr>
+      </p:cxnSp>
+      <p:cxnSp>
+        <p:nvCxnSpPr>
+          <p:cNvPr id="72" name=""/>
+          <p:cNvCxnSpPr>
+            <a:stCxn xmlns:a="http://schemas.openxmlformats.org/drawingml/2006/main" id="23" idx="3"/>
+            <a:endCxn xmlns:a="http://schemas.openxmlformats.org/drawingml/2006/main" id="24" idx="1"/>
+          </p:cNvCxnSpPr>
+          <p:nvPr/>
+        </p:nvCxnSpPr>
+        <p:spPr>
+          <a:xfrm xmlns:a="http://schemas.openxmlformats.org/drawingml/2006/main">
+            <a:off x="6857929" y="4874688"/>
+            <a:ext cx="1800402" cy="45797"/>
+          </a:xfrm>
+          <a:prstGeom xmlns:a="http://schemas.openxmlformats.org/drawingml/2006/main" prst="straightConnector1">
+            <a:avLst/>
+          </a:prstGeom>
+          <a:ln xmlns:a="http://schemas.openxmlformats.org/drawingml/2006/main" w="26670" cap="rnd">
+            <a:solidFill>
+              <a:srgbClr val="202124"/>
+            </a:solidFill>
+            <a:prstDash val="solid"/>
+            <a:round/>
+            <a:headEnd type="none" w="med" len="med"/>
+            <a:tailEnd type="triangle" w="med" len="med"/>
+          </a:ln>
+        </p:spPr>
+      </p:cxnSp>
+      <p:cxnSp>
+        <p:nvCxnSpPr>
+          <p:cNvPr id="73" name=""/>
+          <p:cNvCxnSpPr>
+            <a:stCxn xmlns:a="http://schemas.openxmlformats.org/drawingml/2006/main" id="24" idx="2"/>
+            <a:endCxn xmlns:a="http://schemas.openxmlformats.org/drawingml/2006/main" id="22" idx="2"/>
+          </p:cNvCxnSpPr>
+          <p:nvPr/>
+        </p:nvCxnSpPr>
+        <p:spPr>
+          <a:xfrm xmlns:a="http://schemas.openxmlformats.org/drawingml/2006/main" flipH="1" flipV="1">
+            <a:off x="2239588" y="5410134"/>
+            <a:ext cx="7268406" cy="7"/>
+          </a:xfrm>
+          <a:prstGeom xmlns:a="http://schemas.openxmlformats.org/drawingml/2006/main" prst="straightConnector1">
+            <a:avLst/>
+          </a:prstGeom>
+          <a:ln xmlns:a="http://schemas.openxmlformats.org/drawingml/2006/main" w="26670" cap="rnd">
+            <a:solidFill>
+              <a:srgbClr val="202124"/>
+            </a:solidFill>
+            <a:prstDash val="solid"/>
+            <a:round/>
+            <a:headEnd type="none" w="med" len="med"/>
+            <a:tailEnd type="triangle" w="med" len="med"/>
+          </a:ln>
+        </p:spPr>
+      </p:cxnSp>
     </p:spTree>
     <p:extLst>
       <p:ext uri="{BB962C8B-B14F-4D97-AF65-F5344CB8AC3E}">
@@ -4927,13 +5038,9 @@
           <a:prstGeom xmlns:a="http://schemas.openxmlformats.org/drawingml/2006/main" prst="rightArrow">
             <a:avLst/>
           </a:prstGeom>
-          <a:solidFill xmlns:a="http://schemas.openxmlformats.org/drawingml/2006/main">
-            <a:srgbClr val="202124"/>
-          </a:solidFill>
-          <a:ln xmlns:a="http://schemas.openxmlformats.org/drawingml/2006/main" w="9525">
-            <a:solidFill>
-              <a:srgbClr val="202124"/>
-            </a:solidFill>
+          <a:noFill xmlns:a="http://schemas.openxmlformats.org/drawingml/2006/main"/>
+          <a:ln xmlns:a="http://schemas.openxmlformats.org/drawingml/2006/main" w="0">
+            <a:noFill/>
             <a:prstDash val="solid"/>
           </a:ln>
         </p:spPr>
@@ -4960,13 +5067,9 @@
           <a:prstGeom xmlns:a="http://schemas.openxmlformats.org/drawingml/2006/main" prst="rightArrow">
             <a:avLst/>
           </a:prstGeom>
-          <a:solidFill xmlns:a="http://schemas.openxmlformats.org/drawingml/2006/main">
-            <a:srgbClr val="202124"/>
-          </a:solidFill>
-          <a:ln xmlns:a="http://schemas.openxmlformats.org/drawingml/2006/main" w="9525">
-            <a:solidFill>
-              <a:srgbClr val="202124"/>
-            </a:solidFill>
+          <a:noFill xmlns:a="http://schemas.openxmlformats.org/drawingml/2006/main"/>
+          <a:ln xmlns:a="http://schemas.openxmlformats.org/drawingml/2006/main" w="0">
+            <a:noFill/>
             <a:prstDash val="solid"/>
           </a:ln>
         </p:spPr>
@@ -4993,13 +5096,9 @@
           <a:prstGeom xmlns:a="http://schemas.openxmlformats.org/drawingml/2006/main" prst="rightArrow">
             <a:avLst/>
           </a:prstGeom>
-          <a:solidFill xmlns:a="http://schemas.openxmlformats.org/drawingml/2006/main">
-            <a:srgbClr val="202124"/>
-          </a:solidFill>
-          <a:ln xmlns:a="http://schemas.openxmlformats.org/drawingml/2006/main" w="9525">
-            <a:solidFill>
-              <a:srgbClr val="202124"/>
-            </a:solidFill>
+          <a:noFill xmlns:a="http://schemas.openxmlformats.org/drawingml/2006/main"/>
+          <a:ln xmlns:a="http://schemas.openxmlformats.org/drawingml/2006/main" w="0">
+            <a:noFill/>
             <a:prstDash val="solid"/>
           </a:ln>
         </p:spPr>
@@ -6508,6 +6607,90 @@
           </a:p>
         </p:txBody>
       </p:sp>
+      <p:cxnSp>
+        <p:nvCxnSpPr>
+          <p:cNvPr id="69" name=""/>
+          <p:cNvCxnSpPr>
+            <a:stCxn xmlns:a="http://schemas.openxmlformats.org/drawingml/2006/main" id="8" idx="3"/>
+            <a:endCxn xmlns:a="http://schemas.openxmlformats.org/drawingml/2006/main" id="11" idx="1"/>
+          </p:cNvCxnSpPr>
+          <p:nvPr/>
+        </p:nvCxnSpPr>
+        <p:spPr>
+          <a:xfrm xmlns:a="http://schemas.openxmlformats.org/drawingml/2006/main" flipV="1">
+            <a:off x="2952612" y="3442946"/>
+            <a:ext cx="876540" cy="113137"/>
+          </a:xfrm>
+          <a:prstGeom xmlns:a="http://schemas.openxmlformats.org/drawingml/2006/main" prst="straightConnector1">
+            <a:avLst/>
+          </a:prstGeom>
+          <a:ln xmlns:a="http://schemas.openxmlformats.org/drawingml/2006/main" w="26670" cap="rnd">
+            <a:solidFill>
+              <a:srgbClr val="202124"/>
+            </a:solidFill>
+            <a:prstDash val="solid"/>
+            <a:round/>
+            <a:headEnd type="none" w="med" len="med"/>
+            <a:tailEnd type="triangle" w="med" len="med"/>
+          </a:ln>
+        </p:spPr>
+      </p:cxnSp>
+      <p:cxnSp>
+        <p:nvCxnSpPr>
+          <p:cNvPr id="70" name=""/>
+          <p:cNvCxnSpPr>
+            <a:stCxn xmlns:a="http://schemas.openxmlformats.org/drawingml/2006/main" id="11" idx="3"/>
+            <a:endCxn xmlns:a="http://schemas.openxmlformats.org/drawingml/2006/main" id="14" idx="1"/>
+          </p:cNvCxnSpPr>
+          <p:nvPr/>
+        </p:nvCxnSpPr>
+        <p:spPr>
+          <a:xfrm xmlns:a="http://schemas.openxmlformats.org/drawingml/2006/main">
+            <a:off x="5924448" y="3472204"/>
+            <a:ext cx="876444" cy="4455"/>
+          </a:xfrm>
+          <a:prstGeom xmlns:a="http://schemas.openxmlformats.org/drawingml/2006/main" prst="straightConnector1">
+            <a:avLst/>
+          </a:prstGeom>
+          <a:ln xmlns:a="http://schemas.openxmlformats.org/drawingml/2006/main" w="26670" cap="rnd">
+            <a:solidFill>
+              <a:srgbClr val="202124"/>
+            </a:solidFill>
+            <a:prstDash val="solid"/>
+            <a:round/>
+            <a:headEnd type="none" w="med" len="med"/>
+            <a:tailEnd type="triangle" w="med" len="med"/>
+          </a:ln>
+        </p:spPr>
+      </p:cxnSp>
+      <p:cxnSp>
+        <p:nvCxnSpPr>
+          <p:cNvPr id="71" name=""/>
+          <p:cNvCxnSpPr>
+            <a:stCxn xmlns:a="http://schemas.openxmlformats.org/drawingml/2006/main" id="14" idx="3"/>
+            <a:endCxn xmlns:a="http://schemas.openxmlformats.org/drawingml/2006/main" id="26" idx="1"/>
+          </p:cNvCxnSpPr>
+          <p:nvPr/>
+        </p:nvCxnSpPr>
+        <p:spPr>
+          <a:xfrm xmlns:a="http://schemas.openxmlformats.org/drawingml/2006/main">
+            <a:off x="8991558" y="3457541"/>
+            <a:ext cx="819348" cy="99373"/>
+          </a:xfrm>
+          <a:prstGeom xmlns:a="http://schemas.openxmlformats.org/drawingml/2006/main" prst="straightConnector1">
+            <a:avLst/>
+          </a:prstGeom>
+          <a:ln xmlns:a="http://schemas.openxmlformats.org/drawingml/2006/main" w="26670" cap="rnd">
+            <a:solidFill>
+              <a:srgbClr val="202124"/>
+            </a:solidFill>
+            <a:prstDash val="solid"/>
+            <a:round/>
+            <a:headEnd type="none" w="med" len="med"/>
+            <a:tailEnd type="triangle" w="med" len="med"/>
+          </a:ln>
+        </p:spPr>
+      </p:cxnSp>
     </p:spTree>
     <p:extLst>
       <p:ext uri="{BB962C8B-B14F-4D97-AF65-F5344CB8AC3E}">
@@ -6776,13 +6959,9 @@
           <a:prstGeom xmlns:a="http://schemas.openxmlformats.org/drawingml/2006/main" prst="rightArrow">
             <a:avLst/>
           </a:prstGeom>
-          <a:solidFill xmlns:a="http://schemas.openxmlformats.org/drawingml/2006/main">
-            <a:srgbClr val="202124"/>
-          </a:solidFill>
-          <a:ln xmlns:a="http://schemas.openxmlformats.org/drawingml/2006/main" w="9525">
-            <a:solidFill>
-              <a:srgbClr val="202124"/>
-            </a:solidFill>
+          <a:noFill xmlns:a="http://schemas.openxmlformats.org/drawingml/2006/main"/>
+          <a:ln xmlns:a="http://schemas.openxmlformats.org/drawingml/2006/main" w="0">
+            <a:noFill/>
             <a:prstDash val="solid"/>
           </a:ln>
         </p:spPr>
@@ -6809,13 +6988,9 @@
           <a:prstGeom xmlns:a="http://schemas.openxmlformats.org/drawingml/2006/main" prst="rightArrow">
             <a:avLst/>
           </a:prstGeom>
-          <a:solidFill xmlns:a="http://schemas.openxmlformats.org/drawingml/2006/main">
-            <a:srgbClr val="202124"/>
-          </a:solidFill>
-          <a:ln xmlns:a="http://schemas.openxmlformats.org/drawingml/2006/main" w="9525">
-            <a:solidFill>
-              <a:srgbClr val="202124"/>
-            </a:solidFill>
+          <a:noFill xmlns:a="http://schemas.openxmlformats.org/drawingml/2006/main"/>
+          <a:ln xmlns:a="http://schemas.openxmlformats.org/drawingml/2006/main" w="0">
+            <a:noFill/>
             <a:prstDash val="solid"/>
           </a:ln>
         </p:spPr>
@@ -6842,13 +7017,9 @@
           <a:prstGeom xmlns:a="http://schemas.openxmlformats.org/drawingml/2006/main" prst="rightArrow">
             <a:avLst/>
           </a:prstGeom>
-          <a:solidFill xmlns:a="http://schemas.openxmlformats.org/drawingml/2006/main">
-            <a:srgbClr val="202124"/>
-          </a:solidFill>
-          <a:ln xmlns:a="http://schemas.openxmlformats.org/drawingml/2006/main" w="9525">
-            <a:solidFill>
-              <a:srgbClr val="202124"/>
-            </a:solidFill>
+          <a:noFill xmlns:a="http://schemas.openxmlformats.org/drawingml/2006/main"/>
+          <a:ln xmlns:a="http://schemas.openxmlformats.org/drawingml/2006/main" w="0">
+            <a:noFill/>
             <a:prstDash val="solid"/>
           </a:ln>
         </p:spPr>
@@ -6875,13 +7046,9 @@
           <a:prstGeom xmlns:a="http://schemas.openxmlformats.org/drawingml/2006/main" prst="leftArrow">
             <a:avLst/>
           </a:prstGeom>
-          <a:solidFill xmlns:a="http://schemas.openxmlformats.org/drawingml/2006/main">
-            <a:srgbClr val="202124"/>
-          </a:solidFill>
-          <a:ln xmlns:a="http://schemas.openxmlformats.org/drawingml/2006/main" w="9525">
-            <a:solidFill>
-              <a:srgbClr val="202124"/>
-            </a:solidFill>
+          <a:noFill xmlns:a="http://schemas.openxmlformats.org/drawingml/2006/main"/>
+          <a:ln xmlns:a="http://schemas.openxmlformats.org/drawingml/2006/main" w="0">
+            <a:noFill/>
             <a:prstDash val="solid"/>
           </a:ln>
         </p:spPr>
@@ -8193,6 +8360,230 @@
           </a:p>
         </p:txBody>
       </p:sp>
+      <p:cxnSp>
+        <p:nvCxnSpPr>
+          <p:cNvPr id="66" name=""/>
+          <p:cNvCxnSpPr>
+            <a:stCxn xmlns:a="http://schemas.openxmlformats.org/drawingml/2006/main" id="9" idx="3"/>
+            <a:endCxn xmlns:a="http://schemas.openxmlformats.org/drawingml/2006/main" id="12" idx="1"/>
+          </p:cNvCxnSpPr>
+          <p:nvPr/>
+        </p:nvCxnSpPr>
+        <p:spPr>
+          <a:xfrm xmlns:a="http://schemas.openxmlformats.org/drawingml/2006/main" flipV="1">
+            <a:off x="2685898" y="3006667"/>
+            <a:ext cx="1409920" cy="809691"/>
+          </a:xfrm>
+          <a:prstGeom xmlns:a="http://schemas.openxmlformats.org/drawingml/2006/main" prst="straightConnector1">
+            <a:avLst/>
+          </a:prstGeom>
+          <a:ln xmlns:a="http://schemas.openxmlformats.org/drawingml/2006/main" w="26670" cap="rnd">
+            <a:solidFill>
+              <a:srgbClr val="202124"/>
+            </a:solidFill>
+            <a:prstDash val="solid"/>
+            <a:round/>
+            <a:headEnd type="none" w="med" len="med"/>
+            <a:tailEnd type="triangle" w="med" len="med"/>
+          </a:ln>
+        </p:spPr>
+      </p:cxnSp>
+      <p:cxnSp>
+        <p:nvCxnSpPr>
+          <p:cNvPr id="67" name=""/>
+          <p:cNvCxnSpPr>
+            <a:stCxn xmlns:a="http://schemas.openxmlformats.org/drawingml/2006/main" id="12" idx="3"/>
+            <a:endCxn xmlns:a="http://schemas.openxmlformats.org/drawingml/2006/main" id="15" idx="1"/>
+          </p:cNvCxnSpPr>
+          <p:nvPr/>
+        </p:nvCxnSpPr>
+        <p:spPr>
+          <a:xfrm xmlns:a="http://schemas.openxmlformats.org/drawingml/2006/main" flipV="1">
+            <a:off x="5905432" y="2981649"/>
+            <a:ext cx="666915" cy="2909"/>
+          </a:xfrm>
+          <a:prstGeom xmlns:a="http://schemas.openxmlformats.org/drawingml/2006/main" prst="straightConnector1">
+            <a:avLst/>
+          </a:prstGeom>
+          <a:ln xmlns:a="http://schemas.openxmlformats.org/drawingml/2006/main" w="26670" cap="rnd">
+            <a:solidFill>
+              <a:srgbClr val="202124"/>
+            </a:solidFill>
+            <a:prstDash val="solid"/>
+            <a:round/>
+            <a:headEnd type="none" w="med" len="med"/>
+            <a:tailEnd type="triangle" w="med" len="med"/>
+          </a:ln>
+        </p:spPr>
+      </p:cxnSp>
+      <p:cxnSp>
+        <p:nvCxnSpPr>
+          <p:cNvPr id="68" name=""/>
+          <p:cNvCxnSpPr>
+            <a:stCxn xmlns:a="http://schemas.openxmlformats.org/drawingml/2006/main" id="15" idx="3"/>
+            <a:endCxn xmlns:a="http://schemas.openxmlformats.org/drawingml/2006/main" id="23" idx="1"/>
+          </p:cNvCxnSpPr>
+          <p:nvPr/>
+        </p:nvCxnSpPr>
+        <p:spPr>
+          <a:xfrm xmlns:a="http://schemas.openxmlformats.org/drawingml/2006/main">
+            <a:off x="8572403" y="3009576"/>
+            <a:ext cx="1333721" cy="810106"/>
+          </a:xfrm>
+          <a:prstGeom xmlns:a="http://schemas.openxmlformats.org/drawingml/2006/main" prst="straightConnector1">
+            <a:avLst/>
+          </a:prstGeom>
+          <a:ln xmlns:a="http://schemas.openxmlformats.org/drawingml/2006/main" w="26670" cap="rnd">
+            <a:solidFill>
+              <a:srgbClr val="202124"/>
+            </a:solidFill>
+            <a:prstDash val="solid"/>
+            <a:round/>
+            <a:headEnd type="none" w="med" len="med"/>
+            <a:tailEnd type="triangle" w="med" len="med"/>
+          </a:ln>
+        </p:spPr>
+      </p:cxnSp>
+      <p:cxnSp>
+        <p:nvCxnSpPr>
+          <p:cNvPr id="69" name=""/>
+          <p:cNvCxnSpPr>
+            <a:stCxn xmlns:a="http://schemas.openxmlformats.org/drawingml/2006/main" id="9" idx="3"/>
+            <a:endCxn xmlns:a="http://schemas.openxmlformats.org/drawingml/2006/main" id="18" idx="1"/>
+          </p:cNvCxnSpPr>
+          <p:nvPr/>
+        </p:nvCxnSpPr>
+        <p:spPr>
+          <a:xfrm xmlns:a="http://schemas.openxmlformats.org/drawingml/2006/main">
+            <a:off x="2685898" y="3816358"/>
+            <a:ext cx="1219427" cy="678328"/>
+          </a:xfrm>
+          <a:prstGeom xmlns:a="http://schemas.openxmlformats.org/drawingml/2006/main" prst="straightConnector1">
+            <a:avLst/>
+          </a:prstGeom>
+          <a:ln xmlns:a="http://schemas.openxmlformats.org/drawingml/2006/main" w="26670" cap="rnd">
+            <a:solidFill>
+              <a:srgbClr val="202124"/>
+            </a:solidFill>
+            <a:prstDash val="solid"/>
+            <a:round/>
+            <a:headEnd type="none" w="med" len="med"/>
+            <a:tailEnd type="triangle" w="med" len="med"/>
+          </a:ln>
+        </p:spPr>
+      </p:cxnSp>
+      <p:cxnSp>
+        <p:nvCxnSpPr>
+          <p:cNvPr id="70" name=""/>
+          <p:cNvCxnSpPr>
+            <a:stCxn xmlns:a="http://schemas.openxmlformats.org/drawingml/2006/main" id="18" idx="3"/>
+            <a:endCxn xmlns:a="http://schemas.openxmlformats.org/drawingml/2006/main" id="20" idx="1"/>
+          </p:cNvCxnSpPr>
+          <p:nvPr/>
+        </p:nvCxnSpPr>
+        <p:spPr>
+          <a:xfrm xmlns:a="http://schemas.openxmlformats.org/drawingml/2006/main" flipV="1">
+            <a:off x="5429176" y="4468339"/>
+            <a:ext cx="247799" cy="47625"/>
+          </a:xfrm>
+          <a:prstGeom xmlns:a="http://schemas.openxmlformats.org/drawingml/2006/main" prst="straightConnector1">
+            <a:avLst/>
+          </a:prstGeom>
+          <a:ln xmlns:a="http://schemas.openxmlformats.org/drawingml/2006/main" w="26670" cap="rnd">
+            <a:solidFill>
+              <a:srgbClr val="202124"/>
+            </a:solidFill>
+            <a:prstDash val="solid"/>
+            <a:round/>
+            <a:headEnd type="none" w="med" len="med"/>
+            <a:tailEnd type="triangle" w="med" len="med"/>
+          </a:ln>
+        </p:spPr>
+      </p:cxnSp>
+      <p:cxnSp>
+        <p:nvCxnSpPr>
+          <p:cNvPr id="71" name=""/>
+          <p:cNvCxnSpPr>
+            <a:stCxn xmlns:a="http://schemas.openxmlformats.org/drawingml/2006/main" id="20" idx="3"/>
+            <a:endCxn xmlns:a="http://schemas.openxmlformats.org/drawingml/2006/main" id="22" idx="1"/>
+          </p:cNvCxnSpPr>
+          <p:nvPr/>
+        </p:nvCxnSpPr>
+        <p:spPr>
+          <a:xfrm xmlns:a="http://schemas.openxmlformats.org/drawingml/2006/main">
+            <a:off x="7200826" y="4447061"/>
+            <a:ext cx="247766" cy="50285"/>
+          </a:xfrm>
+          <a:prstGeom xmlns:a="http://schemas.openxmlformats.org/drawingml/2006/main" prst="straightConnector1">
+            <a:avLst/>
+          </a:prstGeom>
+          <a:ln xmlns:a="http://schemas.openxmlformats.org/drawingml/2006/main" w="26670" cap="rnd">
+            <a:solidFill>
+              <a:srgbClr val="202124"/>
+            </a:solidFill>
+            <a:prstDash val="solid"/>
+            <a:round/>
+            <a:headEnd type="none" w="med" len="med"/>
+            <a:tailEnd type="triangle" w="med" len="med"/>
+          </a:ln>
+        </p:spPr>
+      </p:cxnSp>
+      <p:cxnSp>
+        <p:nvCxnSpPr>
+          <p:cNvPr id="72" name=""/>
+          <p:cNvCxnSpPr>
+            <a:stCxn xmlns:a="http://schemas.openxmlformats.org/drawingml/2006/main" id="22" idx="3"/>
+            <a:endCxn xmlns:a="http://schemas.openxmlformats.org/drawingml/2006/main" id="23" idx="1"/>
+          </p:cNvCxnSpPr>
+          <p:nvPr/>
+        </p:nvCxnSpPr>
+        <p:spPr>
+          <a:xfrm xmlns:a="http://schemas.openxmlformats.org/drawingml/2006/main" flipV="1">
+            <a:off x="8972508" y="3819683"/>
+            <a:ext cx="933615" cy="693622"/>
+          </a:xfrm>
+          <a:prstGeom xmlns:a="http://schemas.openxmlformats.org/drawingml/2006/main" prst="straightConnector1">
+            <a:avLst/>
+          </a:prstGeom>
+          <a:ln xmlns:a="http://schemas.openxmlformats.org/drawingml/2006/main" w="26670" cap="rnd">
+            <a:solidFill>
+              <a:srgbClr val="202124"/>
+            </a:solidFill>
+            <a:prstDash val="solid"/>
+            <a:round/>
+            <a:headEnd type="none" w="med" len="med"/>
+            <a:tailEnd type="triangle" w="med" len="med"/>
+          </a:ln>
+        </p:spPr>
+      </p:cxnSp>
+      <p:cxnSp>
+        <p:nvCxnSpPr>
+          <p:cNvPr id="73" name=""/>
+          <p:cNvCxnSpPr>
+            <a:stCxn xmlns:a="http://schemas.openxmlformats.org/drawingml/2006/main" id="22" idx="2"/>
+            <a:endCxn xmlns:a="http://schemas.openxmlformats.org/drawingml/2006/main" id="18" idx="2"/>
+          </p:cNvCxnSpPr>
+          <p:nvPr/>
+        </p:nvCxnSpPr>
+        <p:spPr>
+          <a:xfrm xmlns:a="http://schemas.openxmlformats.org/drawingml/2006/main" flipH="1" flipV="1">
+            <a:off x="4661265" y="4933917"/>
+            <a:ext cx="3544796" cy="9"/>
+          </a:xfrm>
+          <a:prstGeom xmlns:a="http://schemas.openxmlformats.org/drawingml/2006/main" prst="straightConnector1">
+            <a:avLst/>
+          </a:prstGeom>
+          <a:ln xmlns:a="http://schemas.openxmlformats.org/drawingml/2006/main" w="26670" cap="rnd">
+            <a:solidFill>
+              <a:srgbClr val="202124"/>
+            </a:solidFill>
+            <a:prstDash val="solid"/>
+            <a:round/>
+            <a:headEnd type="none" w="med" len="med"/>
+            <a:tailEnd type="triangle" w="med" len="med"/>
+          </a:ln>
+        </p:spPr>
+      </p:cxnSp>
     </p:spTree>
     <p:extLst>
       <p:ext uri="{BB962C8B-B14F-4D97-AF65-F5344CB8AC3E}">
@@ -10451,13 +10842,9 @@
           <a:prstGeom xmlns:a="http://schemas.openxmlformats.org/drawingml/2006/main" prst="line">
             <a:avLst/>
           </a:prstGeom>
-          <a:solidFill xmlns:a="http://schemas.openxmlformats.org/drawingml/2006/main">
-            <a:srgbClr val="202124"/>
-          </a:solidFill>
-          <a:ln xmlns:a="http://schemas.openxmlformats.org/drawingml/2006/main" w="28575">
-            <a:solidFill>
-              <a:srgbClr val="202124"/>
-            </a:solidFill>
+          <a:noFill xmlns:a="http://schemas.openxmlformats.org/drawingml/2006/main"/>
+          <a:ln xmlns:a="http://schemas.openxmlformats.org/drawingml/2006/main" w="0">
+            <a:noFill/>
             <a:prstDash val="solid"/>
           </a:ln>
         </p:spPr>
@@ -12383,6 +12770,62 @@
           </a:p>
         </p:txBody>
       </p:sp>
+      <p:cxnSp>
+        <p:nvCxnSpPr>
+          <p:cNvPr id="68" name=""/>
+          <p:cNvCxnSpPr>
+            <a:stCxn xmlns:a="http://schemas.openxmlformats.org/drawingml/2006/main" id="12" idx="3"/>
+            <a:endCxn xmlns:a="http://schemas.openxmlformats.org/drawingml/2006/main" id="18" idx="1"/>
+          </p:cNvCxnSpPr>
+          <p:nvPr/>
+        </p:nvCxnSpPr>
+        <p:spPr>
+          <a:xfrm xmlns:a="http://schemas.openxmlformats.org/drawingml/2006/main" flipV="1">
+            <a:off x="3714672" y="4296224"/>
+            <a:ext cx="952613" cy="4987"/>
+          </a:xfrm>
+          <a:prstGeom xmlns:a="http://schemas.openxmlformats.org/drawingml/2006/main" prst="straightConnector1">
+            <a:avLst/>
+          </a:prstGeom>
+          <a:ln xmlns:a="http://schemas.openxmlformats.org/drawingml/2006/main" w="30480" cap="rnd">
+            <a:solidFill>
+              <a:srgbClr val="202124"/>
+            </a:solidFill>
+            <a:prstDash val="solid"/>
+            <a:round/>
+            <a:headEnd type="none" w="med" len="med"/>
+            <a:tailEnd type="triangle" w="med" len="med"/>
+          </a:ln>
+        </p:spPr>
+      </p:cxnSp>
+      <p:cxnSp>
+        <p:nvCxnSpPr>
+          <p:cNvPr id="69" name=""/>
+          <p:cNvCxnSpPr>
+            <a:stCxn xmlns:a="http://schemas.openxmlformats.org/drawingml/2006/main" id="18" idx="3"/>
+            <a:endCxn xmlns:a="http://schemas.openxmlformats.org/drawingml/2006/main" id="24" idx="1"/>
+          </p:cNvCxnSpPr>
+          <p:nvPr/>
+        </p:nvCxnSpPr>
+        <p:spPr>
+          <a:xfrm xmlns:a="http://schemas.openxmlformats.org/drawingml/2006/main">
+            <a:off x="7524715" y="4276276"/>
+            <a:ext cx="952589" cy="22443"/>
+          </a:xfrm>
+          <a:prstGeom xmlns:a="http://schemas.openxmlformats.org/drawingml/2006/main" prst="straightConnector1">
+            <a:avLst/>
+          </a:prstGeom>
+          <a:ln xmlns:a="http://schemas.openxmlformats.org/drawingml/2006/main" w="30480" cap="rnd">
+            <a:solidFill>
+              <a:srgbClr val="202124"/>
+            </a:solidFill>
+            <a:prstDash val="solid"/>
+            <a:round/>
+            <a:headEnd type="none" w="med" len="med"/>
+            <a:tailEnd type="triangle" w="med" len="med"/>
+          </a:ln>
+        </p:spPr>
+      </p:cxnSp>
     </p:spTree>
     <p:extLst>
       <p:ext uri="{BB962C8B-B14F-4D97-AF65-F5344CB8AC3E}">

</xml_diff>

<commit_message>
Revert "draft: connect presentation process arrows"
This reverts commit 2215483468cb37b5541de4ec5da71b9f976ade28.
</commit_message>
<xml_diff>
--- a/output/presentations/AI-analytics-review-platform-MTS-DRAFT.pptx
+++ b/output/presentations/AI-analytics-review-platform-MTS-DRAFT.pptx
@@ -2,18 +2,18 @@
 <file path=ppt/presentation.xml><?xml version="1.0" encoding="utf-8"?>
 <p:presentation xmlns:p="http://schemas.openxmlformats.org/presentationml/2006/main">
   <p:sldMasterIdLst>
-    <p:sldMasterId xmlns:r="http://schemas.openxmlformats.org/officeDocument/2006/relationships" id="2147483648" r:id="Rcb0d0076608e4ff0"/>
+    <p:sldMasterId xmlns:r="http://schemas.openxmlformats.org/officeDocument/2006/relationships" id="2147483648" r:id="R1b63cd91cf0f4ea1"/>
   </p:sldMasterIdLst>
   <p:notesMasterIdLst>
-    <p:notesMasterId xmlns:r="http://schemas.openxmlformats.org/officeDocument/2006/relationships" r:id="Rd0be81fe0564457b"/>
+    <p:notesMasterId xmlns:r="http://schemas.openxmlformats.org/officeDocument/2006/relationships" r:id="R24c51b8c5f294dca"/>
   </p:notesMasterIdLst>
   <p:sldIdLst>
-    <p:sldId xmlns:r="http://schemas.openxmlformats.org/officeDocument/2006/relationships" id="256" r:id="R313f53c951b24ae8"/>
-    <p:sldId xmlns:r="http://schemas.openxmlformats.org/officeDocument/2006/relationships" id="257" r:id="R3e0c7a1cc7434bee"/>
-    <p:sldId xmlns:r="http://schemas.openxmlformats.org/officeDocument/2006/relationships" id="258" r:id="R942001dc98e04b7e"/>
-    <p:sldId xmlns:r="http://schemas.openxmlformats.org/officeDocument/2006/relationships" id="259" r:id="R01f30281623a4d06"/>
-    <p:sldId xmlns:r="http://schemas.openxmlformats.org/officeDocument/2006/relationships" id="260" r:id="R0894c0d20e6a4755"/>
-    <p:sldId xmlns:r="http://schemas.openxmlformats.org/officeDocument/2006/relationships" id="261" r:id="Ra7a9d80ca0c444cf"/>
+    <p:sldId xmlns:r="http://schemas.openxmlformats.org/officeDocument/2006/relationships" id="256" r:id="Ra6cc553922bd4fe6"/>
+    <p:sldId xmlns:r="http://schemas.openxmlformats.org/officeDocument/2006/relationships" id="257" r:id="R445a851148074e4a"/>
+    <p:sldId xmlns:r="http://schemas.openxmlformats.org/officeDocument/2006/relationships" id="258" r:id="R035296ca511e40cd"/>
+    <p:sldId xmlns:r="http://schemas.openxmlformats.org/officeDocument/2006/relationships" id="259" r:id="Rc14c4d59c54d4ce7"/>
+    <p:sldId xmlns:r="http://schemas.openxmlformats.org/officeDocument/2006/relationships" id="260" r:id="Rb3149ba09a7c4f59"/>
+    <p:sldId xmlns:r="http://schemas.openxmlformats.org/officeDocument/2006/relationships" id="261" r:id="R95acec03ab1c4b1a"/>
   </p:sldIdLst>
   <p:sldSz cx="12192000" cy="6858000"/>
   <p:notesSz cx="6858000" cy="9144000"/>
@@ -363,6 +363,15 @@
             </a:outerShdw>
           </a:effectLst>
         </a:effectStyle>
+        <a:effectStyle>
+          <a:effectLst>
+            <a:outerShdw blurRad="142875" dist="69343" dir="4443276">
+              <a:srgbClr val="000000">
+                <a:alpha val="18000"/>
+              </a:srgbClr>
+            </a:outerShdw>
+          </a:effectLst>
+        </a:effectStyle>
       </a:effectStyleLst>
       <a:bgFillStyleLst>
         <a:solidFill>
@@ -1035,7 +1044,7 @@
   </p:cSld>
   <p:clrMap bg1="lt1" tx1="dk1" bg2="lt2" tx2="dk2" accent1="accent1" accent2="accent2" accent3="accent3" accent4="accent4" accent5="accent5" accent6="accent6" hlink="hlink" folHlink="folHlink"/>
   <p:sldLayoutIdLst>
-    <p:sldLayoutId xmlns:r="http://schemas.openxmlformats.org/officeDocument/2006/relationships" id="2147483649" r:id="R18c4a33786ae437a"/>
+    <p:sldLayoutId xmlns:r="http://schemas.openxmlformats.org/officeDocument/2006/relationships" id="2147483649" r:id="R2092da32d6e24555"/>
   </p:sldLayoutIdLst>
   <p:txStyles>
     <p:titleStyle>
@@ -1913,9 +1922,13 @@
           <a:prstGeom xmlns:a="http://schemas.openxmlformats.org/drawingml/2006/main" prst="rightArrow">
             <a:avLst/>
           </a:prstGeom>
-          <a:noFill xmlns:a="http://schemas.openxmlformats.org/drawingml/2006/main"/>
-          <a:ln xmlns:a="http://schemas.openxmlformats.org/drawingml/2006/main" w="0">
-            <a:noFill/>
+          <a:solidFill xmlns:a="http://schemas.openxmlformats.org/drawingml/2006/main">
+            <a:srgbClr val="202124"/>
+          </a:solidFill>
+          <a:ln xmlns:a="http://schemas.openxmlformats.org/drawingml/2006/main" w="9525">
+            <a:solidFill>
+              <a:srgbClr val="202124"/>
+            </a:solidFill>
             <a:prstDash val="solid"/>
           </a:ln>
         </p:spPr>
@@ -1942,9 +1955,13 @@
           <a:prstGeom xmlns:a="http://schemas.openxmlformats.org/drawingml/2006/main" prst="rightArrow">
             <a:avLst/>
           </a:prstGeom>
-          <a:noFill xmlns:a="http://schemas.openxmlformats.org/drawingml/2006/main"/>
-          <a:ln xmlns:a="http://schemas.openxmlformats.org/drawingml/2006/main" w="0">
-            <a:noFill/>
+          <a:solidFill xmlns:a="http://schemas.openxmlformats.org/drawingml/2006/main">
+            <a:srgbClr val="202124"/>
+          </a:solidFill>
+          <a:ln xmlns:a="http://schemas.openxmlformats.org/drawingml/2006/main" w="9525">
+            <a:solidFill>
+              <a:srgbClr val="202124"/>
+            </a:solidFill>
             <a:prstDash val="solid"/>
           </a:ln>
         </p:spPr>
@@ -2540,9 +2557,13 @@
           <a:prstGeom xmlns:a="http://schemas.openxmlformats.org/drawingml/2006/main" prst="rightArrow">
             <a:avLst/>
           </a:prstGeom>
-          <a:noFill xmlns:a="http://schemas.openxmlformats.org/drawingml/2006/main"/>
-          <a:ln xmlns:a="http://schemas.openxmlformats.org/drawingml/2006/main" w="0">
-            <a:noFill/>
+          <a:solidFill xmlns:a="http://schemas.openxmlformats.org/drawingml/2006/main">
+            <a:srgbClr val="202124"/>
+          </a:solidFill>
+          <a:ln xmlns:a="http://schemas.openxmlformats.org/drawingml/2006/main" w="9525">
+            <a:solidFill>
+              <a:srgbClr val="202124"/>
+            </a:solidFill>
             <a:prstDash val="solid"/>
           </a:ln>
         </p:spPr>
@@ -2569,9 +2590,13 @@
           <a:prstGeom xmlns:a="http://schemas.openxmlformats.org/drawingml/2006/main" prst="rightArrow">
             <a:avLst/>
           </a:prstGeom>
-          <a:noFill xmlns:a="http://schemas.openxmlformats.org/drawingml/2006/main"/>
-          <a:ln xmlns:a="http://schemas.openxmlformats.org/drawingml/2006/main" w="0">
-            <a:noFill/>
+          <a:solidFill xmlns:a="http://schemas.openxmlformats.org/drawingml/2006/main">
+            <a:srgbClr val="202124"/>
+          </a:solidFill>
+          <a:ln xmlns:a="http://schemas.openxmlformats.org/drawingml/2006/main" w="9525">
+            <a:solidFill>
+              <a:srgbClr val="202124"/>
+            </a:solidFill>
             <a:prstDash val="solid"/>
           </a:ln>
         </p:spPr>
@@ -3023,31 +3048,97 @@
           <a:prstGeom xmlns:a="http://schemas.openxmlformats.org/drawingml/2006/main" prst="leftArrow">
             <a:avLst/>
           </a:prstGeom>
+          <a:solidFill xmlns:a="http://schemas.openxmlformats.org/drawingml/2006/main">
+            <a:srgbClr val="202124"/>
+          </a:solidFill>
+          <a:ln xmlns:a="http://schemas.openxmlformats.org/drawingml/2006/main" w="9525">
+            <a:solidFill>
+              <a:srgbClr val="202124"/>
+            </a:solidFill>
+            <a:prstDash val="solid"/>
+          </a:ln>
+        </p:spPr>
+      </p:sp>
+      <p:sp>
+        <p:nvSpPr>
+          <p:cNvPr id="30" name="return-caption">
+            <a:extLst xmlns:a="http://schemas.openxmlformats.org/drawingml/2006/main">
+              <a:ext uri="{FF2B5EF4-FFF2-40B4-BE49-F238E27FC236}">
+                <a16:creationId xmlns:a16="http://schemas.microsoft.com/office/drawing/2014/main" id="{B0F8A3AC-0E32-442D-819F-6D6E5DFAF304}"/>
+              </a:ext>
+            </a:extLst>
+          </p:cNvPr>
+          <p:cNvSpPr>
+            <a:spLocks xmlns:a="http://schemas.openxmlformats.org/drawingml/2006/main" noGrp="1"/>
+          </p:cNvSpPr>
+          <p:nvPr/>
+        </p:nvSpPr>
+        <p:spPr>
+          <a:xfrm xmlns:a="http://schemas.openxmlformats.org/drawingml/2006/main">
+            <a:off x="3619500" y="5486400"/>
+            <a:ext cx="4476750" cy="247650"/>
+          </a:xfrm>
+          <a:prstGeom xmlns:a="http://schemas.openxmlformats.org/drawingml/2006/main" prst="rect">
+            <a:avLst/>
+          </a:prstGeom>
           <a:noFill xmlns:a="http://schemas.openxmlformats.org/drawingml/2006/main"/>
           <a:ln xmlns:a="http://schemas.openxmlformats.org/drawingml/2006/main" w="0">
             <a:noFill/>
             <a:prstDash val="solid"/>
           </a:ln>
         </p:spPr>
-      </p:sp>
-      <p:sp>
-        <p:nvSpPr>
-          <p:cNvPr id="30" name="return-caption">
-            <a:extLst xmlns:a="http://schemas.openxmlformats.org/drawingml/2006/main">
-              <a:ext uri="{FF2B5EF4-FFF2-40B4-BE49-F238E27FC236}">
-                <a16:creationId xmlns:a16="http://schemas.microsoft.com/office/drawing/2014/main" id="{B0F8A3AC-0E32-442D-819F-6D6E5DFAF304}"/>
-              </a:ext>
-            </a:extLst>
-          </p:cNvPr>
-          <p:cNvSpPr>
-            <a:spLocks xmlns:a="http://schemas.openxmlformats.org/drawingml/2006/main" noGrp="1"/>
-          </p:cNvSpPr>
-          <p:nvPr/>
-        </p:nvSpPr>
-        <p:spPr>
-          <a:xfrm xmlns:a="http://schemas.openxmlformats.org/drawingml/2006/main">
-            <a:off x="3619500" y="5486400"/>
-            <a:ext cx="4476750" cy="247650"/>
+        <p:txBody>
+          <a:bodyPr xmlns:a="http://schemas.openxmlformats.org/drawingml/2006/main" wrap="square" lIns="57150" tIns="38100" rIns="57150" bIns="38100" anchor="ctr">
+            <a:normAutofit fontScale="100000"/>
+          </a:bodyPr>
+          <a:lstStyle xmlns:a="http://schemas.openxmlformats.org/drawingml/2006/main"/>
+          <a:p xmlns:a="http://schemas.openxmlformats.org/drawingml/2006/main">
+            <a:pPr algn="ctr">
+              <a:lnSpc>
+                <a:spcPct val="100000"/>
+              </a:lnSpc>
+              <a:buNone/>
+              <a:defRPr sz="1125" b="0">
+                <a:solidFill>
+                  <a:srgbClr val="202124"/>
+                </a:solidFill>
+                <a:latin typeface="Arial"/>
+                <a:ea typeface="Arial"/>
+                <a:cs typeface="Arial"/>
+              </a:defRPr>
+            </a:pPr>
+            <a:r>
+              <a:rPr sz="1125" b="0">
+                <a:solidFill>
+                  <a:srgbClr val="202124"/>
+                </a:solidFill>
+                <a:latin typeface="Arial"/>
+                <a:ea typeface="Arial"/>
+                <a:cs typeface="Arial"/>
+              </a:rPr>
+              <a:t>короткая петля: уточнение возвращается аналитику</a:t>
+            </a:r>
+          </a:p>
+        </p:txBody>
+      </p:sp>
+      <p:sp>
+        <p:nvSpPr>
+          <p:cNvPr id="31" name="discipline-1">
+            <a:extLst xmlns:a="http://schemas.openxmlformats.org/drawingml/2006/main">
+              <a:ext uri="{FF2B5EF4-FFF2-40B4-BE49-F238E27FC236}">
+                <a16:creationId xmlns:a16="http://schemas.microsoft.com/office/drawing/2014/main" id="{56261578-717D-4F6C-8511-AB4DAB2917E8}"/>
+              </a:ext>
+            </a:extLst>
+          </p:cNvPr>
+          <p:cNvSpPr>
+            <a:spLocks xmlns:a="http://schemas.openxmlformats.org/drawingml/2006/main" noGrp="1"/>
+          </p:cNvSpPr>
+          <p:nvPr/>
+        </p:nvSpPr>
+        <p:spPr>
+          <a:xfrm xmlns:a="http://schemas.openxmlformats.org/drawingml/2006/main">
+            <a:off x="609600" y="6096000"/>
+            <a:ext cx="10972800" cy="323850"/>
           </a:xfrm>
           <a:prstGeom xmlns:a="http://schemas.openxmlformats.org/drawingml/2006/main" prst="rect">
             <a:avLst/>
@@ -3069,68 +3160,6 @@
                 <a:spcPct val="100000"/>
               </a:lnSpc>
               <a:buNone/>
-              <a:defRPr sz="1125" b="0">
-                <a:solidFill>
-                  <a:srgbClr val="202124"/>
-                </a:solidFill>
-                <a:latin typeface="Arial"/>
-                <a:ea typeface="Arial"/>
-                <a:cs typeface="Arial"/>
-              </a:defRPr>
-            </a:pPr>
-            <a:r>
-              <a:rPr sz="1125" b="0">
-                <a:solidFill>
-                  <a:srgbClr val="202124"/>
-                </a:solidFill>
-                <a:latin typeface="Arial"/>
-                <a:ea typeface="Arial"/>
-                <a:cs typeface="Arial"/>
-              </a:rPr>
-              <a:t>короткая петля: уточнение возвращается аналитику</a:t>
-            </a:r>
-          </a:p>
-        </p:txBody>
-      </p:sp>
-      <p:sp>
-        <p:nvSpPr>
-          <p:cNvPr id="31" name="discipline-1">
-            <a:extLst xmlns:a="http://schemas.openxmlformats.org/drawingml/2006/main">
-              <a:ext uri="{FF2B5EF4-FFF2-40B4-BE49-F238E27FC236}">
-                <a16:creationId xmlns:a16="http://schemas.microsoft.com/office/drawing/2014/main" id="{56261578-717D-4F6C-8511-AB4DAB2917E8}"/>
-              </a:ext>
-            </a:extLst>
-          </p:cNvPr>
-          <p:cNvSpPr>
-            <a:spLocks xmlns:a="http://schemas.openxmlformats.org/drawingml/2006/main" noGrp="1"/>
-          </p:cNvSpPr>
-          <p:nvPr/>
-        </p:nvSpPr>
-        <p:spPr>
-          <a:xfrm xmlns:a="http://schemas.openxmlformats.org/drawingml/2006/main">
-            <a:off x="609600" y="6096000"/>
-            <a:ext cx="10972800" cy="323850"/>
-          </a:xfrm>
-          <a:prstGeom xmlns:a="http://schemas.openxmlformats.org/drawingml/2006/main" prst="rect">
-            <a:avLst/>
-          </a:prstGeom>
-          <a:noFill xmlns:a="http://schemas.openxmlformats.org/drawingml/2006/main"/>
-          <a:ln xmlns:a="http://schemas.openxmlformats.org/drawingml/2006/main" w="0">
-            <a:noFill/>
-            <a:prstDash val="solid"/>
-          </a:ln>
-        </p:spPr>
-        <p:txBody>
-          <a:bodyPr xmlns:a="http://schemas.openxmlformats.org/drawingml/2006/main" wrap="square" lIns="57150" tIns="38100" rIns="57150" bIns="38100" anchor="ctr">
-            <a:normAutofit fontScale="100000"/>
-          </a:bodyPr>
-          <a:lstStyle xmlns:a="http://schemas.openxmlformats.org/drawingml/2006/main"/>
-          <a:p xmlns:a="http://schemas.openxmlformats.org/drawingml/2006/main">
-            <a:pPr algn="ctr">
-              <a:lnSpc>
-                <a:spcPct val="100000"/>
-              </a:lnSpc>
-              <a:buNone/>
               <a:defRPr sz="1425" b="1">
                 <a:solidFill>
                   <a:srgbClr val="B80D18"/>
@@ -3154,146 +3183,6 @@
           </a:p>
         </p:txBody>
       </p:sp>
-      <p:cxnSp>
-        <p:nvCxnSpPr>
-          <p:cNvPr id="69" name=""/>
-          <p:cNvCxnSpPr>
-            <a:stCxn xmlns:a="http://schemas.openxmlformats.org/drawingml/2006/main" id="10" idx="3"/>
-            <a:endCxn xmlns:a="http://schemas.openxmlformats.org/drawingml/2006/main" id="11" idx="1"/>
-          </p:cNvCxnSpPr>
-          <p:nvPr/>
-        </p:nvCxnSpPr>
-        <p:spPr>
-          <a:xfrm xmlns:a="http://schemas.openxmlformats.org/drawingml/2006/main" flipV="1">
-            <a:off x="3009722" y="2902016"/>
-            <a:ext cx="1990991" cy="33779"/>
-          </a:xfrm>
-          <a:prstGeom xmlns:a="http://schemas.openxmlformats.org/drawingml/2006/main" prst="straightConnector1">
-            <a:avLst/>
-          </a:prstGeom>
-          <a:ln xmlns:a="http://schemas.openxmlformats.org/drawingml/2006/main" w="26670" cap="rnd">
-            <a:solidFill>
-              <a:srgbClr val="202124"/>
-            </a:solidFill>
-            <a:prstDash val="solid"/>
-            <a:round/>
-            <a:headEnd type="none" w="med" len="med"/>
-            <a:tailEnd type="triangle" w="med" len="med"/>
-          </a:ln>
-        </p:spPr>
-      </p:cxnSp>
-      <p:cxnSp>
-        <p:nvCxnSpPr>
-          <p:cNvPr id="70" name=""/>
-          <p:cNvCxnSpPr>
-            <a:stCxn xmlns:a="http://schemas.openxmlformats.org/drawingml/2006/main" id="11" idx="3"/>
-            <a:endCxn xmlns:a="http://schemas.openxmlformats.org/drawingml/2006/main" id="12" idx="1"/>
-          </p:cNvCxnSpPr>
-          <p:nvPr/>
-        </p:nvCxnSpPr>
-        <p:spPr>
-          <a:xfrm xmlns:a="http://schemas.openxmlformats.org/drawingml/2006/main">
-            <a:off x="6810287" y="2927284"/>
-            <a:ext cx="1886187" cy="9923"/>
-          </a:xfrm>
-          <a:prstGeom xmlns:a="http://schemas.openxmlformats.org/drawingml/2006/main" prst="straightConnector1">
-            <a:avLst/>
-          </a:prstGeom>
-          <a:ln xmlns:a="http://schemas.openxmlformats.org/drawingml/2006/main" w="26670" cap="rnd">
-            <a:solidFill>
-              <a:srgbClr val="202124"/>
-            </a:solidFill>
-            <a:prstDash val="solid"/>
-            <a:round/>
-            <a:headEnd type="none" w="med" len="med"/>
-            <a:tailEnd type="triangle" w="med" len="med"/>
-          </a:ln>
-        </p:spPr>
-      </p:cxnSp>
-      <p:cxnSp>
-        <p:nvCxnSpPr>
-          <p:cNvPr id="71" name=""/>
-          <p:cNvCxnSpPr>
-            <a:stCxn xmlns:a="http://schemas.openxmlformats.org/drawingml/2006/main" id="22" idx="3"/>
-            <a:endCxn xmlns:a="http://schemas.openxmlformats.org/drawingml/2006/main" id="23" idx="1"/>
-          </p:cNvCxnSpPr>
-          <p:nvPr/>
-        </p:nvCxnSpPr>
-        <p:spPr>
-          <a:xfrm xmlns:a="http://schemas.openxmlformats.org/drawingml/2006/main" flipV="1">
-            <a:off x="3105019" y="4897962"/>
-            <a:ext cx="1848052" cy="50949"/>
-          </a:xfrm>
-          <a:prstGeom xmlns:a="http://schemas.openxmlformats.org/drawingml/2006/main" prst="straightConnector1">
-            <a:avLst/>
-          </a:prstGeom>
-          <a:ln xmlns:a="http://schemas.openxmlformats.org/drawingml/2006/main" w="26670" cap="rnd">
-            <a:solidFill>
-              <a:srgbClr val="202124"/>
-            </a:solidFill>
-            <a:prstDash val="solid"/>
-            <a:round/>
-            <a:headEnd type="none" w="med" len="med"/>
-            <a:tailEnd type="triangle" w="med" len="med"/>
-          </a:ln>
-        </p:spPr>
-      </p:cxnSp>
-      <p:cxnSp>
-        <p:nvCxnSpPr>
-          <p:cNvPr id="72" name=""/>
-          <p:cNvCxnSpPr>
-            <a:stCxn xmlns:a="http://schemas.openxmlformats.org/drawingml/2006/main" id="23" idx="3"/>
-            <a:endCxn xmlns:a="http://schemas.openxmlformats.org/drawingml/2006/main" id="24" idx="1"/>
-          </p:cNvCxnSpPr>
-          <p:nvPr/>
-        </p:nvCxnSpPr>
-        <p:spPr>
-          <a:xfrm xmlns:a="http://schemas.openxmlformats.org/drawingml/2006/main">
-            <a:off x="6857929" y="4874688"/>
-            <a:ext cx="1800402" cy="45797"/>
-          </a:xfrm>
-          <a:prstGeom xmlns:a="http://schemas.openxmlformats.org/drawingml/2006/main" prst="straightConnector1">
-            <a:avLst/>
-          </a:prstGeom>
-          <a:ln xmlns:a="http://schemas.openxmlformats.org/drawingml/2006/main" w="26670" cap="rnd">
-            <a:solidFill>
-              <a:srgbClr val="202124"/>
-            </a:solidFill>
-            <a:prstDash val="solid"/>
-            <a:round/>
-            <a:headEnd type="none" w="med" len="med"/>
-            <a:tailEnd type="triangle" w="med" len="med"/>
-          </a:ln>
-        </p:spPr>
-      </p:cxnSp>
-      <p:cxnSp>
-        <p:nvCxnSpPr>
-          <p:cNvPr id="73" name=""/>
-          <p:cNvCxnSpPr>
-            <a:stCxn xmlns:a="http://schemas.openxmlformats.org/drawingml/2006/main" id="24" idx="2"/>
-            <a:endCxn xmlns:a="http://schemas.openxmlformats.org/drawingml/2006/main" id="22" idx="2"/>
-          </p:cNvCxnSpPr>
-          <p:nvPr/>
-        </p:nvCxnSpPr>
-        <p:spPr>
-          <a:xfrm xmlns:a="http://schemas.openxmlformats.org/drawingml/2006/main" flipH="1" flipV="1">
-            <a:off x="2239588" y="5410134"/>
-            <a:ext cx="7268406" cy="7"/>
-          </a:xfrm>
-          <a:prstGeom xmlns:a="http://schemas.openxmlformats.org/drawingml/2006/main" prst="straightConnector1">
-            <a:avLst/>
-          </a:prstGeom>
-          <a:ln xmlns:a="http://schemas.openxmlformats.org/drawingml/2006/main" w="26670" cap="rnd">
-            <a:solidFill>
-              <a:srgbClr val="202124"/>
-            </a:solidFill>
-            <a:prstDash val="solid"/>
-            <a:round/>
-            <a:headEnd type="none" w="med" len="med"/>
-            <a:tailEnd type="triangle" w="med" len="med"/>
-          </a:ln>
-        </p:spPr>
-      </p:cxnSp>
     </p:spTree>
     <p:extLst>
       <p:ext uri="{BB962C8B-B14F-4D97-AF65-F5344CB8AC3E}">
@@ -5038,9 +4927,13 @@
           <a:prstGeom xmlns:a="http://schemas.openxmlformats.org/drawingml/2006/main" prst="rightArrow">
             <a:avLst/>
           </a:prstGeom>
-          <a:noFill xmlns:a="http://schemas.openxmlformats.org/drawingml/2006/main"/>
-          <a:ln xmlns:a="http://schemas.openxmlformats.org/drawingml/2006/main" w="0">
-            <a:noFill/>
+          <a:solidFill xmlns:a="http://schemas.openxmlformats.org/drawingml/2006/main">
+            <a:srgbClr val="202124"/>
+          </a:solidFill>
+          <a:ln xmlns:a="http://schemas.openxmlformats.org/drawingml/2006/main" w="9525">
+            <a:solidFill>
+              <a:srgbClr val="202124"/>
+            </a:solidFill>
             <a:prstDash val="solid"/>
           </a:ln>
         </p:spPr>
@@ -5067,9 +4960,13 @@
           <a:prstGeom xmlns:a="http://schemas.openxmlformats.org/drawingml/2006/main" prst="rightArrow">
             <a:avLst/>
           </a:prstGeom>
-          <a:noFill xmlns:a="http://schemas.openxmlformats.org/drawingml/2006/main"/>
-          <a:ln xmlns:a="http://schemas.openxmlformats.org/drawingml/2006/main" w="0">
-            <a:noFill/>
+          <a:solidFill xmlns:a="http://schemas.openxmlformats.org/drawingml/2006/main">
+            <a:srgbClr val="202124"/>
+          </a:solidFill>
+          <a:ln xmlns:a="http://schemas.openxmlformats.org/drawingml/2006/main" w="9525">
+            <a:solidFill>
+              <a:srgbClr val="202124"/>
+            </a:solidFill>
             <a:prstDash val="solid"/>
           </a:ln>
         </p:spPr>
@@ -5096,9 +4993,13 @@
           <a:prstGeom xmlns:a="http://schemas.openxmlformats.org/drawingml/2006/main" prst="rightArrow">
             <a:avLst/>
           </a:prstGeom>
-          <a:noFill xmlns:a="http://schemas.openxmlformats.org/drawingml/2006/main"/>
-          <a:ln xmlns:a="http://schemas.openxmlformats.org/drawingml/2006/main" w="0">
-            <a:noFill/>
+          <a:solidFill xmlns:a="http://schemas.openxmlformats.org/drawingml/2006/main">
+            <a:srgbClr val="202124"/>
+          </a:solidFill>
+          <a:ln xmlns:a="http://schemas.openxmlformats.org/drawingml/2006/main" w="9525">
+            <a:solidFill>
+              <a:srgbClr val="202124"/>
+            </a:solidFill>
             <a:prstDash val="solid"/>
           </a:ln>
         </p:spPr>
@@ -6607,90 +6508,6 @@
           </a:p>
         </p:txBody>
       </p:sp>
-      <p:cxnSp>
-        <p:nvCxnSpPr>
-          <p:cNvPr id="69" name=""/>
-          <p:cNvCxnSpPr>
-            <a:stCxn xmlns:a="http://schemas.openxmlformats.org/drawingml/2006/main" id="8" idx="3"/>
-            <a:endCxn xmlns:a="http://schemas.openxmlformats.org/drawingml/2006/main" id="11" idx="1"/>
-          </p:cNvCxnSpPr>
-          <p:nvPr/>
-        </p:nvCxnSpPr>
-        <p:spPr>
-          <a:xfrm xmlns:a="http://schemas.openxmlformats.org/drawingml/2006/main" flipV="1">
-            <a:off x="2952612" y="3442946"/>
-            <a:ext cx="876540" cy="113137"/>
-          </a:xfrm>
-          <a:prstGeom xmlns:a="http://schemas.openxmlformats.org/drawingml/2006/main" prst="straightConnector1">
-            <a:avLst/>
-          </a:prstGeom>
-          <a:ln xmlns:a="http://schemas.openxmlformats.org/drawingml/2006/main" w="26670" cap="rnd">
-            <a:solidFill>
-              <a:srgbClr val="202124"/>
-            </a:solidFill>
-            <a:prstDash val="solid"/>
-            <a:round/>
-            <a:headEnd type="none" w="med" len="med"/>
-            <a:tailEnd type="triangle" w="med" len="med"/>
-          </a:ln>
-        </p:spPr>
-      </p:cxnSp>
-      <p:cxnSp>
-        <p:nvCxnSpPr>
-          <p:cNvPr id="70" name=""/>
-          <p:cNvCxnSpPr>
-            <a:stCxn xmlns:a="http://schemas.openxmlformats.org/drawingml/2006/main" id="11" idx="3"/>
-            <a:endCxn xmlns:a="http://schemas.openxmlformats.org/drawingml/2006/main" id="14" idx="1"/>
-          </p:cNvCxnSpPr>
-          <p:nvPr/>
-        </p:nvCxnSpPr>
-        <p:spPr>
-          <a:xfrm xmlns:a="http://schemas.openxmlformats.org/drawingml/2006/main">
-            <a:off x="5924448" y="3472204"/>
-            <a:ext cx="876444" cy="4455"/>
-          </a:xfrm>
-          <a:prstGeom xmlns:a="http://schemas.openxmlformats.org/drawingml/2006/main" prst="straightConnector1">
-            <a:avLst/>
-          </a:prstGeom>
-          <a:ln xmlns:a="http://schemas.openxmlformats.org/drawingml/2006/main" w="26670" cap="rnd">
-            <a:solidFill>
-              <a:srgbClr val="202124"/>
-            </a:solidFill>
-            <a:prstDash val="solid"/>
-            <a:round/>
-            <a:headEnd type="none" w="med" len="med"/>
-            <a:tailEnd type="triangle" w="med" len="med"/>
-          </a:ln>
-        </p:spPr>
-      </p:cxnSp>
-      <p:cxnSp>
-        <p:nvCxnSpPr>
-          <p:cNvPr id="71" name=""/>
-          <p:cNvCxnSpPr>
-            <a:stCxn xmlns:a="http://schemas.openxmlformats.org/drawingml/2006/main" id="14" idx="3"/>
-            <a:endCxn xmlns:a="http://schemas.openxmlformats.org/drawingml/2006/main" id="26" idx="1"/>
-          </p:cNvCxnSpPr>
-          <p:nvPr/>
-        </p:nvCxnSpPr>
-        <p:spPr>
-          <a:xfrm xmlns:a="http://schemas.openxmlformats.org/drawingml/2006/main">
-            <a:off x="8991558" y="3457541"/>
-            <a:ext cx="819348" cy="99373"/>
-          </a:xfrm>
-          <a:prstGeom xmlns:a="http://schemas.openxmlformats.org/drawingml/2006/main" prst="straightConnector1">
-            <a:avLst/>
-          </a:prstGeom>
-          <a:ln xmlns:a="http://schemas.openxmlformats.org/drawingml/2006/main" w="26670" cap="rnd">
-            <a:solidFill>
-              <a:srgbClr val="202124"/>
-            </a:solidFill>
-            <a:prstDash val="solid"/>
-            <a:round/>
-            <a:headEnd type="none" w="med" len="med"/>
-            <a:tailEnd type="triangle" w="med" len="med"/>
-          </a:ln>
-        </p:spPr>
-      </p:cxnSp>
     </p:spTree>
     <p:extLst>
       <p:ext uri="{BB962C8B-B14F-4D97-AF65-F5344CB8AC3E}">
@@ -6959,9 +6776,13 @@
           <a:prstGeom xmlns:a="http://schemas.openxmlformats.org/drawingml/2006/main" prst="rightArrow">
             <a:avLst/>
           </a:prstGeom>
-          <a:noFill xmlns:a="http://schemas.openxmlformats.org/drawingml/2006/main"/>
-          <a:ln xmlns:a="http://schemas.openxmlformats.org/drawingml/2006/main" w="0">
-            <a:noFill/>
+          <a:solidFill xmlns:a="http://schemas.openxmlformats.org/drawingml/2006/main">
+            <a:srgbClr val="202124"/>
+          </a:solidFill>
+          <a:ln xmlns:a="http://schemas.openxmlformats.org/drawingml/2006/main" w="9525">
+            <a:solidFill>
+              <a:srgbClr val="202124"/>
+            </a:solidFill>
             <a:prstDash val="solid"/>
           </a:ln>
         </p:spPr>
@@ -6988,9 +6809,13 @@
           <a:prstGeom xmlns:a="http://schemas.openxmlformats.org/drawingml/2006/main" prst="rightArrow">
             <a:avLst/>
           </a:prstGeom>
-          <a:noFill xmlns:a="http://schemas.openxmlformats.org/drawingml/2006/main"/>
-          <a:ln xmlns:a="http://schemas.openxmlformats.org/drawingml/2006/main" w="0">
-            <a:noFill/>
+          <a:solidFill xmlns:a="http://schemas.openxmlformats.org/drawingml/2006/main">
+            <a:srgbClr val="202124"/>
+          </a:solidFill>
+          <a:ln xmlns:a="http://schemas.openxmlformats.org/drawingml/2006/main" w="9525">
+            <a:solidFill>
+              <a:srgbClr val="202124"/>
+            </a:solidFill>
             <a:prstDash val="solid"/>
           </a:ln>
         </p:spPr>
@@ -7017,9 +6842,13 @@
           <a:prstGeom xmlns:a="http://schemas.openxmlformats.org/drawingml/2006/main" prst="rightArrow">
             <a:avLst/>
           </a:prstGeom>
-          <a:noFill xmlns:a="http://schemas.openxmlformats.org/drawingml/2006/main"/>
-          <a:ln xmlns:a="http://schemas.openxmlformats.org/drawingml/2006/main" w="0">
-            <a:noFill/>
+          <a:solidFill xmlns:a="http://schemas.openxmlformats.org/drawingml/2006/main">
+            <a:srgbClr val="202124"/>
+          </a:solidFill>
+          <a:ln xmlns:a="http://schemas.openxmlformats.org/drawingml/2006/main" w="9525">
+            <a:solidFill>
+              <a:srgbClr val="202124"/>
+            </a:solidFill>
             <a:prstDash val="solid"/>
           </a:ln>
         </p:spPr>
@@ -7046,9 +6875,13 @@
           <a:prstGeom xmlns:a="http://schemas.openxmlformats.org/drawingml/2006/main" prst="leftArrow">
             <a:avLst/>
           </a:prstGeom>
-          <a:noFill xmlns:a="http://schemas.openxmlformats.org/drawingml/2006/main"/>
-          <a:ln xmlns:a="http://schemas.openxmlformats.org/drawingml/2006/main" w="0">
-            <a:noFill/>
+          <a:solidFill xmlns:a="http://schemas.openxmlformats.org/drawingml/2006/main">
+            <a:srgbClr val="202124"/>
+          </a:solidFill>
+          <a:ln xmlns:a="http://schemas.openxmlformats.org/drawingml/2006/main" w="9525">
+            <a:solidFill>
+              <a:srgbClr val="202124"/>
+            </a:solidFill>
             <a:prstDash val="solid"/>
           </a:ln>
         </p:spPr>
@@ -8360,230 +8193,6 @@
           </a:p>
         </p:txBody>
       </p:sp>
-      <p:cxnSp>
-        <p:nvCxnSpPr>
-          <p:cNvPr id="66" name=""/>
-          <p:cNvCxnSpPr>
-            <a:stCxn xmlns:a="http://schemas.openxmlformats.org/drawingml/2006/main" id="9" idx="3"/>
-            <a:endCxn xmlns:a="http://schemas.openxmlformats.org/drawingml/2006/main" id="12" idx="1"/>
-          </p:cNvCxnSpPr>
-          <p:nvPr/>
-        </p:nvCxnSpPr>
-        <p:spPr>
-          <a:xfrm xmlns:a="http://schemas.openxmlformats.org/drawingml/2006/main" flipV="1">
-            <a:off x="2685898" y="3006667"/>
-            <a:ext cx="1409920" cy="809691"/>
-          </a:xfrm>
-          <a:prstGeom xmlns:a="http://schemas.openxmlformats.org/drawingml/2006/main" prst="straightConnector1">
-            <a:avLst/>
-          </a:prstGeom>
-          <a:ln xmlns:a="http://schemas.openxmlformats.org/drawingml/2006/main" w="26670" cap="rnd">
-            <a:solidFill>
-              <a:srgbClr val="202124"/>
-            </a:solidFill>
-            <a:prstDash val="solid"/>
-            <a:round/>
-            <a:headEnd type="none" w="med" len="med"/>
-            <a:tailEnd type="triangle" w="med" len="med"/>
-          </a:ln>
-        </p:spPr>
-      </p:cxnSp>
-      <p:cxnSp>
-        <p:nvCxnSpPr>
-          <p:cNvPr id="67" name=""/>
-          <p:cNvCxnSpPr>
-            <a:stCxn xmlns:a="http://schemas.openxmlformats.org/drawingml/2006/main" id="12" idx="3"/>
-            <a:endCxn xmlns:a="http://schemas.openxmlformats.org/drawingml/2006/main" id="15" idx="1"/>
-          </p:cNvCxnSpPr>
-          <p:nvPr/>
-        </p:nvCxnSpPr>
-        <p:spPr>
-          <a:xfrm xmlns:a="http://schemas.openxmlformats.org/drawingml/2006/main" flipV="1">
-            <a:off x="5905432" y="2981649"/>
-            <a:ext cx="666915" cy="2909"/>
-          </a:xfrm>
-          <a:prstGeom xmlns:a="http://schemas.openxmlformats.org/drawingml/2006/main" prst="straightConnector1">
-            <a:avLst/>
-          </a:prstGeom>
-          <a:ln xmlns:a="http://schemas.openxmlformats.org/drawingml/2006/main" w="26670" cap="rnd">
-            <a:solidFill>
-              <a:srgbClr val="202124"/>
-            </a:solidFill>
-            <a:prstDash val="solid"/>
-            <a:round/>
-            <a:headEnd type="none" w="med" len="med"/>
-            <a:tailEnd type="triangle" w="med" len="med"/>
-          </a:ln>
-        </p:spPr>
-      </p:cxnSp>
-      <p:cxnSp>
-        <p:nvCxnSpPr>
-          <p:cNvPr id="68" name=""/>
-          <p:cNvCxnSpPr>
-            <a:stCxn xmlns:a="http://schemas.openxmlformats.org/drawingml/2006/main" id="15" idx="3"/>
-            <a:endCxn xmlns:a="http://schemas.openxmlformats.org/drawingml/2006/main" id="23" idx="1"/>
-          </p:cNvCxnSpPr>
-          <p:nvPr/>
-        </p:nvCxnSpPr>
-        <p:spPr>
-          <a:xfrm xmlns:a="http://schemas.openxmlformats.org/drawingml/2006/main">
-            <a:off x="8572403" y="3009576"/>
-            <a:ext cx="1333721" cy="810106"/>
-          </a:xfrm>
-          <a:prstGeom xmlns:a="http://schemas.openxmlformats.org/drawingml/2006/main" prst="straightConnector1">
-            <a:avLst/>
-          </a:prstGeom>
-          <a:ln xmlns:a="http://schemas.openxmlformats.org/drawingml/2006/main" w="26670" cap="rnd">
-            <a:solidFill>
-              <a:srgbClr val="202124"/>
-            </a:solidFill>
-            <a:prstDash val="solid"/>
-            <a:round/>
-            <a:headEnd type="none" w="med" len="med"/>
-            <a:tailEnd type="triangle" w="med" len="med"/>
-          </a:ln>
-        </p:spPr>
-      </p:cxnSp>
-      <p:cxnSp>
-        <p:nvCxnSpPr>
-          <p:cNvPr id="69" name=""/>
-          <p:cNvCxnSpPr>
-            <a:stCxn xmlns:a="http://schemas.openxmlformats.org/drawingml/2006/main" id="9" idx="3"/>
-            <a:endCxn xmlns:a="http://schemas.openxmlformats.org/drawingml/2006/main" id="18" idx="1"/>
-          </p:cNvCxnSpPr>
-          <p:nvPr/>
-        </p:nvCxnSpPr>
-        <p:spPr>
-          <a:xfrm xmlns:a="http://schemas.openxmlformats.org/drawingml/2006/main">
-            <a:off x="2685898" y="3816358"/>
-            <a:ext cx="1219427" cy="678328"/>
-          </a:xfrm>
-          <a:prstGeom xmlns:a="http://schemas.openxmlformats.org/drawingml/2006/main" prst="straightConnector1">
-            <a:avLst/>
-          </a:prstGeom>
-          <a:ln xmlns:a="http://schemas.openxmlformats.org/drawingml/2006/main" w="26670" cap="rnd">
-            <a:solidFill>
-              <a:srgbClr val="202124"/>
-            </a:solidFill>
-            <a:prstDash val="solid"/>
-            <a:round/>
-            <a:headEnd type="none" w="med" len="med"/>
-            <a:tailEnd type="triangle" w="med" len="med"/>
-          </a:ln>
-        </p:spPr>
-      </p:cxnSp>
-      <p:cxnSp>
-        <p:nvCxnSpPr>
-          <p:cNvPr id="70" name=""/>
-          <p:cNvCxnSpPr>
-            <a:stCxn xmlns:a="http://schemas.openxmlformats.org/drawingml/2006/main" id="18" idx="3"/>
-            <a:endCxn xmlns:a="http://schemas.openxmlformats.org/drawingml/2006/main" id="20" idx="1"/>
-          </p:cNvCxnSpPr>
-          <p:nvPr/>
-        </p:nvCxnSpPr>
-        <p:spPr>
-          <a:xfrm xmlns:a="http://schemas.openxmlformats.org/drawingml/2006/main" flipV="1">
-            <a:off x="5429176" y="4468339"/>
-            <a:ext cx="247799" cy="47625"/>
-          </a:xfrm>
-          <a:prstGeom xmlns:a="http://schemas.openxmlformats.org/drawingml/2006/main" prst="straightConnector1">
-            <a:avLst/>
-          </a:prstGeom>
-          <a:ln xmlns:a="http://schemas.openxmlformats.org/drawingml/2006/main" w="26670" cap="rnd">
-            <a:solidFill>
-              <a:srgbClr val="202124"/>
-            </a:solidFill>
-            <a:prstDash val="solid"/>
-            <a:round/>
-            <a:headEnd type="none" w="med" len="med"/>
-            <a:tailEnd type="triangle" w="med" len="med"/>
-          </a:ln>
-        </p:spPr>
-      </p:cxnSp>
-      <p:cxnSp>
-        <p:nvCxnSpPr>
-          <p:cNvPr id="71" name=""/>
-          <p:cNvCxnSpPr>
-            <a:stCxn xmlns:a="http://schemas.openxmlformats.org/drawingml/2006/main" id="20" idx="3"/>
-            <a:endCxn xmlns:a="http://schemas.openxmlformats.org/drawingml/2006/main" id="22" idx="1"/>
-          </p:cNvCxnSpPr>
-          <p:nvPr/>
-        </p:nvCxnSpPr>
-        <p:spPr>
-          <a:xfrm xmlns:a="http://schemas.openxmlformats.org/drawingml/2006/main">
-            <a:off x="7200826" y="4447061"/>
-            <a:ext cx="247766" cy="50285"/>
-          </a:xfrm>
-          <a:prstGeom xmlns:a="http://schemas.openxmlformats.org/drawingml/2006/main" prst="straightConnector1">
-            <a:avLst/>
-          </a:prstGeom>
-          <a:ln xmlns:a="http://schemas.openxmlformats.org/drawingml/2006/main" w="26670" cap="rnd">
-            <a:solidFill>
-              <a:srgbClr val="202124"/>
-            </a:solidFill>
-            <a:prstDash val="solid"/>
-            <a:round/>
-            <a:headEnd type="none" w="med" len="med"/>
-            <a:tailEnd type="triangle" w="med" len="med"/>
-          </a:ln>
-        </p:spPr>
-      </p:cxnSp>
-      <p:cxnSp>
-        <p:nvCxnSpPr>
-          <p:cNvPr id="72" name=""/>
-          <p:cNvCxnSpPr>
-            <a:stCxn xmlns:a="http://schemas.openxmlformats.org/drawingml/2006/main" id="22" idx="3"/>
-            <a:endCxn xmlns:a="http://schemas.openxmlformats.org/drawingml/2006/main" id="23" idx="1"/>
-          </p:cNvCxnSpPr>
-          <p:nvPr/>
-        </p:nvCxnSpPr>
-        <p:spPr>
-          <a:xfrm xmlns:a="http://schemas.openxmlformats.org/drawingml/2006/main" flipV="1">
-            <a:off x="8972508" y="3819683"/>
-            <a:ext cx="933615" cy="693622"/>
-          </a:xfrm>
-          <a:prstGeom xmlns:a="http://schemas.openxmlformats.org/drawingml/2006/main" prst="straightConnector1">
-            <a:avLst/>
-          </a:prstGeom>
-          <a:ln xmlns:a="http://schemas.openxmlformats.org/drawingml/2006/main" w="26670" cap="rnd">
-            <a:solidFill>
-              <a:srgbClr val="202124"/>
-            </a:solidFill>
-            <a:prstDash val="solid"/>
-            <a:round/>
-            <a:headEnd type="none" w="med" len="med"/>
-            <a:tailEnd type="triangle" w="med" len="med"/>
-          </a:ln>
-        </p:spPr>
-      </p:cxnSp>
-      <p:cxnSp>
-        <p:nvCxnSpPr>
-          <p:cNvPr id="73" name=""/>
-          <p:cNvCxnSpPr>
-            <a:stCxn xmlns:a="http://schemas.openxmlformats.org/drawingml/2006/main" id="22" idx="2"/>
-            <a:endCxn xmlns:a="http://schemas.openxmlformats.org/drawingml/2006/main" id="18" idx="2"/>
-          </p:cNvCxnSpPr>
-          <p:nvPr/>
-        </p:nvCxnSpPr>
-        <p:spPr>
-          <a:xfrm xmlns:a="http://schemas.openxmlformats.org/drawingml/2006/main" flipH="1" flipV="1">
-            <a:off x="4661265" y="4933917"/>
-            <a:ext cx="3544796" cy="9"/>
-          </a:xfrm>
-          <a:prstGeom xmlns:a="http://schemas.openxmlformats.org/drawingml/2006/main" prst="straightConnector1">
-            <a:avLst/>
-          </a:prstGeom>
-          <a:ln xmlns:a="http://schemas.openxmlformats.org/drawingml/2006/main" w="26670" cap="rnd">
-            <a:solidFill>
-              <a:srgbClr val="202124"/>
-            </a:solidFill>
-            <a:prstDash val="solid"/>
-            <a:round/>
-            <a:headEnd type="none" w="med" len="med"/>
-            <a:tailEnd type="triangle" w="med" len="med"/>
-          </a:ln>
-        </p:spPr>
-      </p:cxnSp>
     </p:spTree>
     <p:extLst>
       <p:ext uri="{BB962C8B-B14F-4D97-AF65-F5344CB8AC3E}">
@@ -10842,9 +10451,13 @@
           <a:prstGeom xmlns:a="http://schemas.openxmlformats.org/drawingml/2006/main" prst="line">
             <a:avLst/>
           </a:prstGeom>
-          <a:noFill xmlns:a="http://schemas.openxmlformats.org/drawingml/2006/main"/>
-          <a:ln xmlns:a="http://schemas.openxmlformats.org/drawingml/2006/main" w="0">
-            <a:noFill/>
+          <a:solidFill xmlns:a="http://schemas.openxmlformats.org/drawingml/2006/main">
+            <a:srgbClr val="202124"/>
+          </a:solidFill>
+          <a:ln xmlns:a="http://schemas.openxmlformats.org/drawingml/2006/main" w="28575">
+            <a:solidFill>
+              <a:srgbClr val="202124"/>
+            </a:solidFill>
             <a:prstDash val="solid"/>
           </a:ln>
         </p:spPr>
@@ -12770,62 +12383,6 @@
           </a:p>
         </p:txBody>
       </p:sp>
-      <p:cxnSp>
-        <p:nvCxnSpPr>
-          <p:cNvPr id="68" name=""/>
-          <p:cNvCxnSpPr>
-            <a:stCxn xmlns:a="http://schemas.openxmlformats.org/drawingml/2006/main" id="12" idx="3"/>
-            <a:endCxn xmlns:a="http://schemas.openxmlformats.org/drawingml/2006/main" id="18" idx="1"/>
-          </p:cNvCxnSpPr>
-          <p:nvPr/>
-        </p:nvCxnSpPr>
-        <p:spPr>
-          <a:xfrm xmlns:a="http://schemas.openxmlformats.org/drawingml/2006/main" flipV="1">
-            <a:off x="3714672" y="4296224"/>
-            <a:ext cx="952613" cy="4987"/>
-          </a:xfrm>
-          <a:prstGeom xmlns:a="http://schemas.openxmlformats.org/drawingml/2006/main" prst="straightConnector1">
-            <a:avLst/>
-          </a:prstGeom>
-          <a:ln xmlns:a="http://schemas.openxmlformats.org/drawingml/2006/main" w="30480" cap="rnd">
-            <a:solidFill>
-              <a:srgbClr val="202124"/>
-            </a:solidFill>
-            <a:prstDash val="solid"/>
-            <a:round/>
-            <a:headEnd type="none" w="med" len="med"/>
-            <a:tailEnd type="triangle" w="med" len="med"/>
-          </a:ln>
-        </p:spPr>
-      </p:cxnSp>
-      <p:cxnSp>
-        <p:nvCxnSpPr>
-          <p:cNvPr id="69" name=""/>
-          <p:cNvCxnSpPr>
-            <a:stCxn xmlns:a="http://schemas.openxmlformats.org/drawingml/2006/main" id="18" idx="3"/>
-            <a:endCxn xmlns:a="http://schemas.openxmlformats.org/drawingml/2006/main" id="24" idx="1"/>
-          </p:cNvCxnSpPr>
-          <p:nvPr/>
-        </p:nvCxnSpPr>
-        <p:spPr>
-          <a:xfrm xmlns:a="http://schemas.openxmlformats.org/drawingml/2006/main">
-            <a:off x="7524715" y="4276276"/>
-            <a:ext cx="952589" cy="22443"/>
-          </a:xfrm>
-          <a:prstGeom xmlns:a="http://schemas.openxmlformats.org/drawingml/2006/main" prst="straightConnector1">
-            <a:avLst/>
-          </a:prstGeom>
-          <a:ln xmlns:a="http://schemas.openxmlformats.org/drawingml/2006/main" w="30480" cap="rnd">
-            <a:solidFill>
-              <a:srgbClr val="202124"/>
-            </a:solidFill>
-            <a:prstDash val="solid"/>
-            <a:round/>
-            <a:headEnd type="none" w="med" len="med"/>
-            <a:tailEnd type="triangle" w="med" len="med"/>
-          </a:ln>
-        </p:spPr>
-      </p:cxnSp>
     </p:spTree>
     <p:extLst>
       <p:ext uri="{BB962C8B-B14F-4D97-AF65-F5344CB8AC3E}">

</xml_diff>